<commit_message>
docs: add video demo slide and expand slides technical details
</commit_message>
<xml_diff>
--- a/Prezentare_Licenta_Podean_Beniamin.pptx
+++ b/Prezentare_Licenta_Podean_Beniamin.pptx
@@ -16,6 +16,9 @@
     <p:sldId id="264" r:id="rId15"/>
     <p:sldId id="265" r:id="rId16"/>
     <p:sldId id="266" r:id="rId17"/>
+    <p:sldId id="267" r:id="rId18"/>
+    <p:sldId id="268" r:id="rId19"/>
+    <p:sldId id="269" r:id="rId20"/>
   </p:sldIdLst>
   <p:sldSz cx="12191695" cy="6858000" type="screen4x3"/>
   <p:notesSz cx="6858000" cy="9144000"/>
@@ -3355,7 +3358,7 @@
               </a:defRPr>
             </a:pPr>
             <a:r>
-              <a:t>Interfața Grafică (UX) și Optimizări de Stabilitate</a:t>
+              <a:t>Persistența Datelor, Securitate și Conformitate GDPR</a:t>
             </a:r>
           </a:p>
         </p:txBody>
@@ -3394,7 +3397,7 @@
                 </a:solidFill>
                 <a:latin typeface="Calibri"/>
               </a:rPr>
-              <a:t>Panoul de Vizualizare (Dashboard): </a:t>
+              <a:t>Structura Bazei de Date (SQLite local): </a:t>
             </a:r>
             <a:r>
               <a:rPr sz="1400">
@@ -3403,7 +3406,107 @@
                 </a:solidFill>
                 <a:latin typeface="Calibri"/>
               </a:rPr>
-              <a:t>Grafice evolutive dinamice ce compară canalele text, voce și față pe o linie temporală pentru a surprinde dinamica afectivă a utilizatorului.</a:t>
+              <a:t>Sistem de persistență minimalist într-un singur fișier (mindscan_history.db) cu 5 tabele relaționale:</a:t>
+            </a:r>
+          </a:p>
+          <a:p>
+            <a:pPr lvl="1">
+              <a:spcAft>
+                <a:spcPts val="400"/>
+              </a:spcAft>
+            </a:pPr>
+            <a:r>
+              <a:rPr b="1" sz="1300">
+                <a:solidFill>
+                  <a:srgbClr val="334155"/>
+                </a:solidFill>
+                <a:latin typeface="Calibri"/>
+              </a:rPr>
+              <a:t>chats: </a:t>
+            </a:r>
+            <a:r>
+              <a:rPr sz="1300">
+                <a:solidFill>
+                  <a:srgbClr val="334155"/>
+                </a:solidFill>
+                <a:latin typeface="Calibri"/>
+              </a:rPr>
+              <a:t>Id-ul sesiunii, numele persoanei evaluate și timestamps.</a:t>
+            </a:r>
+          </a:p>
+          <a:p>
+            <a:pPr lvl="1">
+              <a:spcAft>
+                <a:spcPts val="400"/>
+              </a:spcAft>
+            </a:pPr>
+            <a:r>
+              <a:rPr b="1" sz="1300">
+                <a:solidFill>
+                  <a:srgbClr val="334155"/>
+                </a:solidFill>
+                <a:latin typeface="Calibri"/>
+              </a:rPr>
+              <a:t>analize: </a:t>
+            </a:r>
+            <a:r>
+              <a:rPr sz="1300">
+                <a:solidFill>
+                  <a:srgbClr val="334155"/>
+                </a:solidFill>
+                <a:latin typeface="Calibri"/>
+              </a:rPr>
+              <a:t>Istoricul text, scorurile semantice, raționamentul LLM și feedback-ul empatic.</a:t>
+            </a:r>
+          </a:p>
+          <a:p>
+            <a:pPr lvl="1">
+              <a:spcAft>
+                <a:spcPts val="400"/>
+              </a:spcAft>
+            </a:pPr>
+            <a:r>
+              <a:rPr b="1" sz="1300">
+                <a:solidFill>
+                  <a:srgbClr val="334155"/>
+                </a:solidFill>
+                <a:latin typeface="Calibri"/>
+              </a:rPr>
+              <a:t>voice_analysis &amp; face_analysis: </a:t>
+            </a:r>
+            <a:r>
+              <a:rPr sz="1300">
+                <a:solidFill>
+                  <a:srgbClr val="334155"/>
+                </a:solidFill>
+                <a:latin typeface="Calibri"/>
+              </a:rPr>
+              <a:t>Transcrierea audio, parametrii biometrici brut și calea fișierelor pe disc.</a:t>
+            </a:r>
+          </a:p>
+          <a:p>
+            <a:pPr lvl="1">
+              <a:spcAft>
+                <a:spcPts val="400"/>
+              </a:spcAft>
+            </a:pPr>
+            <a:r>
+              <a:rPr b="1" sz="1300">
+                <a:solidFill>
+                  <a:srgbClr val="334155"/>
+                </a:solidFill>
+                <a:latin typeface="Calibri"/>
+              </a:rPr>
+              <a:t>multimodal_analysis: </a:t>
+            </a:r>
+            <a:r>
+              <a:rPr sz="1300">
+                <a:solidFill>
+                  <a:srgbClr val="334155"/>
+                </a:solidFill>
+                <a:latin typeface="Calibri"/>
+              </a:rPr>
+              <a:t>Scorurile agregate finale și încrederea multimodală.</a:t>
             </a:r>
           </a:p>
           <a:p>
@@ -3419,7 +3522,7 @@
                 </a:solidFill>
                 <a:latin typeface="Calibri"/>
               </a:rPr>
-              <a:t>Sistemul de Alertare Critică: </a:t>
+              <a:t>Securitatea Bazelor de Date (SQL Injection): </a:t>
             </a:r>
             <a:r>
               <a:rPr sz="1400">
@@ -3428,57 +3531,7 @@
                 </a:solidFill>
                 <a:latin typeface="Calibri"/>
               </a:rPr>
-              <a:t>Integrarea componentei EmergencyPopup în React:</a:t>
-            </a:r>
-          </a:p>
-          <a:p>
-            <a:pPr lvl="1">
-              <a:spcAft>
-                <a:spcPts val="400"/>
-              </a:spcAft>
-            </a:pPr>
-            <a:r>
-              <a:rPr b="1" sz="1300">
-                <a:solidFill>
-                  <a:srgbClr val="334155"/>
-                </a:solidFill>
-                <a:latin typeface="Calibri"/>
-              </a:rPr>
-              <a:t>Declanșare: </a:t>
-            </a:r>
-            <a:r>
-              <a:rPr sz="1300">
-                <a:solidFill>
-                  <a:srgbClr val="334155"/>
-                </a:solidFill>
-                <a:latin typeface="Calibri"/>
-              </a:rPr>
-              <a:t>La determinarea unui risc combinat clinic de peste 95% (fie prin text, fie prin voce).</a:t>
-            </a:r>
-          </a:p>
-          <a:p>
-            <a:pPr lvl="1">
-              <a:spcAft>
-                <a:spcPts val="400"/>
-              </a:spcAft>
-            </a:pPr>
-            <a:r>
-              <a:rPr b="1" sz="1300">
-                <a:solidFill>
-                  <a:srgbClr val="334155"/>
-                </a:solidFill>
-                <a:latin typeface="Calibri"/>
-              </a:rPr>
-              <a:t>Conținut: </a:t>
-            </a:r>
-            <a:r>
-              <a:rPr sz="1300">
-                <a:solidFill>
-                  <a:srgbClr val="334155"/>
-                </a:solidFill>
-                <a:latin typeface="Calibri"/>
-              </a:rPr>
-              <a:t>Afișarea contactelor de urgență antisuicid naționale (112, Alianța Română Antisuicid) și măsuri imediate de calmare.</a:t>
+              <a:t>Toate interogările folosesc interogări complet parametrizate (prepared statements cu placeholders '?'). Nicio intrare de la utilizator nu este concatenată direct în SQL.</a:t>
             </a:r>
           </a:p>
           <a:p>
@@ -3494,7 +3547,7 @@
                 </a:solidFill>
                 <a:latin typeface="Calibri"/>
               </a:rPr>
-              <a:t>Optimizarea Stabilității Vizuale (Flicker Prevention): </a:t>
+              <a:t>Gestiunea Concurenței: </a:t>
             </a:r>
             <a:r>
               <a:rPr sz="1400">
@@ -3503,57 +3556,32 @@
                 </a:solidFill>
                 <a:latin typeface="Calibri"/>
               </a:rPr>
-              <a:t>Rezolvarea defectelor vizuale majore în timpul înregistrării video/audio:</a:t>
-            </a:r>
-          </a:p>
-          <a:p>
-            <a:pPr lvl="1">
-              <a:spcAft>
-                <a:spcPts val="400"/>
-              </a:spcAft>
-            </a:pPr>
-            <a:r>
-              <a:rPr b="1" sz="1300">
-                <a:solidFill>
-                  <a:srgbClr val="334155"/>
-                </a:solidFill>
-                <a:latin typeface="Calibri"/>
-              </a:rPr>
-              <a:t>Problema: </a:t>
-            </a:r>
-            <a:r>
-              <a:rPr sz="1300">
-                <a:solidFill>
-                  <a:srgbClr val="334155"/>
-                </a:solidFill>
-                <a:latin typeface="Calibri"/>
-              </a:rPr>
-              <a:t>Schimbarea paginilor (tabs) în React demonta componenta Home, cauzând re-decodarea asincronă a imaginilor din carduri (flicker negru pe filmare).</a:t>
-            </a:r>
-          </a:p>
-          <a:p>
-            <a:pPr lvl="1">
-              <a:spcAft>
-                <a:spcPts val="400"/>
-              </a:spcAft>
-            </a:pPr>
-            <a:r>
-              <a:rPr b="1" sz="1300">
-                <a:solidFill>
-                  <a:srgbClr val="334155"/>
-                </a:solidFill>
-                <a:latin typeface="Calibri"/>
-              </a:rPr>
-              <a:t>Soluția React: </a:t>
-            </a:r>
-            <a:r>
-              <a:rPr sz="1300">
-                <a:solidFill>
-                  <a:srgbClr val="334155"/>
-                </a:solidFill>
-                <a:latin typeface="Calibri"/>
-              </a:rPr>
-              <a:t>Modificarea FrontPage.jsx pentru a menține componenta Home montată în DOM în permanență, ascunzând-o/afișând-o prin CSS (display: none / block).</a:t>
+              <a:t>Configurarea unui timeout de 10.0 secunde pe conexiunea SQLite pentru a asigura scrieri concurente ordonate, fără blocarea bazei de date (database locked).</a:t>
+            </a:r>
+          </a:p>
+          <a:p>
+            <a:pPr>
+              <a:spcAft>
+                <a:spcPts val="800"/>
+              </a:spcAft>
+            </a:pPr>
+            <a:r>
+              <a:rPr b="1" sz="1500">
+                <a:solidFill>
+                  <a:srgbClr val="1E293B"/>
+                </a:solidFill>
+                <a:latin typeface="Calibri"/>
+              </a:rPr>
+              <a:t>Ștergerea Securizată (GDPR Compliance): </a:t>
+            </a:r>
+            <a:r>
+              <a:rPr sz="1400">
+                <a:solidFill>
+                  <a:srgbClr val="1E293B"/>
+                </a:solidFill>
+                <a:latin typeface="Calibri"/>
+              </a:rPr>
+              <a:t>La click pe 'Șterge Istoricul', serverul Flask identifică URL-urile din DB, șterge fizic fișierele binare (.wav și .jpg) din folderul uploads/ folosind os.remove(), apoi execută comanda DELETE din tabele.</a:t>
             </a:r>
           </a:p>
         </p:txBody>
@@ -3615,7 +3643,7 @@
               </a:defRPr>
             </a:pPr>
             <a:r>
-              <a:t>Concluzii și Direcții de Dezvoltare Viitoare</a:t>
+              <a:t>Interfața Grafică (UX) și Optimizări de Stabilitate</a:t>
             </a:r>
           </a:p>
         </p:txBody>
@@ -3654,6 +3682,724 @@
                 </a:solidFill>
                 <a:latin typeface="Calibri"/>
               </a:rPr>
+              <a:t>Panoul de Vizualizare (Dashboard): </a:t>
+            </a:r>
+            <a:r>
+              <a:rPr sz="1400">
+                <a:solidFill>
+                  <a:srgbClr val="1E293B"/>
+                </a:solidFill>
+                <a:latin typeface="Calibri"/>
+              </a:rPr>
+              <a:t>Grafice evolutive dinamice ce compară canalele text, voce și față pe o linie temporală pentru a surprinde dinamica afectivă a utilizatorului.</a:t>
+            </a:r>
+          </a:p>
+          <a:p>
+            <a:pPr>
+              <a:spcAft>
+                <a:spcPts val="800"/>
+              </a:spcAft>
+            </a:pPr>
+            <a:r>
+              <a:rPr b="1" sz="1500">
+                <a:solidFill>
+                  <a:srgbClr val="1E293B"/>
+                </a:solidFill>
+                <a:latin typeface="Calibri"/>
+              </a:rPr>
+              <a:t>Sistemul de Alertare Critică: </a:t>
+            </a:r>
+            <a:r>
+              <a:rPr sz="1400">
+                <a:solidFill>
+                  <a:srgbClr val="1E293B"/>
+                </a:solidFill>
+                <a:latin typeface="Calibri"/>
+              </a:rPr>
+              <a:t>Integrarea componentei EmergencyPopup în React:</a:t>
+            </a:r>
+          </a:p>
+          <a:p>
+            <a:pPr lvl="1">
+              <a:spcAft>
+                <a:spcPts val="400"/>
+              </a:spcAft>
+            </a:pPr>
+            <a:r>
+              <a:rPr b="1" sz="1300">
+                <a:solidFill>
+                  <a:srgbClr val="334155"/>
+                </a:solidFill>
+                <a:latin typeface="Calibri"/>
+              </a:rPr>
+              <a:t>Declanșare: </a:t>
+            </a:r>
+            <a:r>
+              <a:rPr sz="1300">
+                <a:solidFill>
+                  <a:srgbClr val="334155"/>
+                </a:solidFill>
+                <a:latin typeface="Calibri"/>
+              </a:rPr>
+              <a:t>La determinarea unui risc combinat clinic de peste 95% (fie prin text, fie prin voce).</a:t>
+            </a:r>
+          </a:p>
+          <a:p>
+            <a:pPr lvl="1">
+              <a:spcAft>
+                <a:spcPts val="400"/>
+              </a:spcAft>
+            </a:pPr>
+            <a:r>
+              <a:rPr b="1" sz="1300">
+                <a:solidFill>
+                  <a:srgbClr val="334155"/>
+                </a:solidFill>
+                <a:latin typeface="Calibri"/>
+              </a:rPr>
+              <a:t>Conținut: </a:t>
+            </a:r>
+            <a:r>
+              <a:rPr sz="1300">
+                <a:solidFill>
+                  <a:srgbClr val="334155"/>
+                </a:solidFill>
+                <a:latin typeface="Calibri"/>
+              </a:rPr>
+              <a:t>Afișarea contactelor de urgență antisuicid naționale (112, Alianța Română Antisuicid) și măsuri imediate de calmare.</a:t>
+            </a:r>
+          </a:p>
+          <a:p>
+            <a:pPr>
+              <a:spcAft>
+                <a:spcPts val="800"/>
+              </a:spcAft>
+            </a:pPr>
+            <a:r>
+              <a:rPr b="1" sz="1500">
+                <a:solidFill>
+                  <a:srgbClr val="1E293B"/>
+                </a:solidFill>
+                <a:latin typeface="Calibri"/>
+              </a:rPr>
+              <a:t>Optimizarea Stabilității Vizuale (Flicker Prevention): </a:t>
+            </a:r>
+            <a:r>
+              <a:rPr sz="1400">
+                <a:solidFill>
+                  <a:srgbClr val="1E293B"/>
+                </a:solidFill>
+                <a:latin typeface="Calibri"/>
+              </a:rPr>
+              <a:t>Rezolvarea defectelor vizuale majore în timpul înregistrării video/audio:</a:t>
+            </a:r>
+          </a:p>
+          <a:p>
+            <a:pPr lvl="1">
+              <a:spcAft>
+                <a:spcPts val="400"/>
+              </a:spcAft>
+            </a:pPr>
+            <a:r>
+              <a:rPr b="1" sz="1300">
+                <a:solidFill>
+                  <a:srgbClr val="334155"/>
+                </a:solidFill>
+                <a:latin typeface="Calibri"/>
+              </a:rPr>
+              <a:t>Problema: </a:t>
+            </a:r>
+            <a:r>
+              <a:rPr sz="1300">
+                <a:solidFill>
+                  <a:srgbClr val="334155"/>
+                </a:solidFill>
+                <a:latin typeface="Calibri"/>
+              </a:rPr>
+              <a:t>Schimbarea paginilor (tabs) în React demonta componenta Home, cauzând re-decodarea asincronă a imaginilor din carduri (flicker negru pe filmare).</a:t>
+            </a:r>
+          </a:p>
+          <a:p>
+            <a:pPr lvl="1">
+              <a:spcAft>
+                <a:spcPts val="400"/>
+              </a:spcAft>
+            </a:pPr>
+            <a:r>
+              <a:rPr b="1" sz="1300">
+                <a:solidFill>
+                  <a:srgbClr val="334155"/>
+                </a:solidFill>
+                <a:latin typeface="Calibri"/>
+              </a:rPr>
+              <a:t>Soluția React: </a:t>
+            </a:r>
+            <a:r>
+              <a:rPr sz="1300">
+                <a:solidFill>
+                  <a:srgbClr val="334155"/>
+                </a:solidFill>
+                <a:latin typeface="Calibri"/>
+              </a:rPr>
+              <a:t>Modificarea FrontPage.jsx pentru a menține componenta Home montată în DOM în permanență, ascunzând-o/afișând-o prin CSS (display: none / block).</a:t>
+            </a:r>
+          </a:p>
+        </p:txBody>
+      </p:sp>
+    </p:spTree>
+  </p:cSld>
+  <p:clrMapOvr>
+    <a:masterClrMapping/>
+  </p:clrMapOvr>
+</p:sld>
+</file>
+
+<file path=ppt/slides/slide12.xml><?xml version="1.0" encoding="utf-8"?>
+<p:sld xmlns:a="http://schemas.openxmlformats.org/drawingml/2006/main" xmlns:p="http://schemas.openxmlformats.org/presentationml/2006/main" xmlns:r="http://schemas.openxmlformats.org/officeDocument/2006/relationships">
+  <p:cSld>
+    <p:bg>
+      <p:bgPr>
+        <a:solidFill>
+          <a:srgbClr val="FFFFFF"/>
+        </a:solidFill>
+        <a:effectLst/>
+      </p:bgPr>
+    </p:bg>
+    <p:spTree>
+      <p:nvGrpSpPr>
+        <p:cNvPr id="1" name=""/>
+        <p:cNvGrpSpPr/>
+        <p:nvPr/>
+      </p:nvGrpSpPr>
+      <p:grpSpPr/>
+      <p:sp>
+        <p:nvSpPr>
+          <p:cNvPr id="2" name="TextBox 1"/>
+          <p:cNvSpPr txBox="1"/>
+          <p:nvPr/>
+        </p:nvSpPr>
+        <p:spPr>
+          <a:xfrm>
+            <a:off x="685800" y="365760"/>
+            <a:ext cx="10817352" cy="731520"/>
+          </a:xfrm>
+          <a:prstGeom prst="rect">
+            <a:avLst/>
+          </a:prstGeom>
+          <a:noFill/>
+        </p:spPr>
+        <p:txBody>
+          <a:bodyPr wrap="square" tIns="0" lIns="0">
+            <a:spAutoFit/>
+          </a:bodyPr>
+          <a:lstStyle/>
+          <a:p>
+            <a:pPr>
+              <a:defRPr sz="2200" b="1">
+                <a:solidFill>
+                  <a:srgbClr val="0F2043"/>
+                </a:solidFill>
+                <a:latin typeface="Arial"/>
+              </a:defRPr>
+            </a:pPr>
+            <a:r>
+              <a:t>Detalii de Implementare &amp; Mediul de Rulare</a:t>
+            </a:r>
+          </a:p>
+        </p:txBody>
+      </p:sp>
+      <p:sp>
+        <p:nvSpPr>
+          <p:cNvPr id="3" name="TextBox 2"/>
+          <p:cNvSpPr txBox="1"/>
+          <p:nvPr/>
+        </p:nvSpPr>
+        <p:spPr>
+          <a:xfrm>
+            <a:off x="685800" y="1097280"/>
+            <a:ext cx="10817352" cy="5303520"/>
+          </a:xfrm>
+          <a:prstGeom prst="rect">
+            <a:avLst/>
+          </a:prstGeom>
+          <a:noFill/>
+        </p:spPr>
+        <p:txBody>
+          <a:bodyPr wrap="square" tIns="0" lIns="0">
+            <a:spAutoFit/>
+          </a:bodyPr>
+          <a:lstStyle/>
+          <a:p>
+            <a:pPr>
+              <a:spcAft>
+                <a:spcPts val="800"/>
+              </a:spcAft>
+            </a:pPr>
+            <a:r>
+              <a:rPr b="1" sz="1500">
+                <a:solidFill>
+                  <a:srgbClr val="1E293B"/>
+                </a:solidFill>
+                <a:latin typeface="Calibri"/>
+              </a:rPr>
+              <a:t>Dependențe Principale Frontend (React &amp; NPM): </a:t>
+            </a:r>
+            <a:r>
+              <a:rPr sz="1400">
+                <a:solidFill>
+                  <a:srgbClr val="1E293B"/>
+                </a:solidFill>
+                <a:latin typeface="Calibri"/>
+              </a:rPr>
+              <a:t>Ecosistem bazat pe Node.js cu module importate:</a:t>
+            </a:r>
+          </a:p>
+          <a:p>
+            <a:pPr lvl="1">
+              <a:spcAft>
+                <a:spcPts val="400"/>
+              </a:spcAft>
+            </a:pPr>
+            <a:r>
+              <a:rPr b="1" sz="1300">
+                <a:solidFill>
+                  <a:srgbClr val="334155"/>
+                </a:solidFill>
+                <a:latin typeface="Calibri"/>
+              </a:rPr>
+              <a:t>react-router-dom: </a:t>
+            </a:r>
+            <a:r>
+              <a:rPr sz="1300">
+                <a:solidFill>
+                  <a:srgbClr val="334155"/>
+                </a:solidFill>
+                <a:latin typeface="Calibri"/>
+              </a:rPr>
+              <a:t>Gestiunea rutelor interne ale paginilor.</a:t>
+            </a:r>
+          </a:p>
+          <a:p>
+            <a:pPr lvl="1">
+              <a:spcAft>
+                <a:spcPts val="400"/>
+              </a:spcAft>
+            </a:pPr>
+            <a:r>
+              <a:rPr b="1" sz="1300">
+                <a:solidFill>
+                  <a:srgbClr val="334155"/>
+                </a:solidFill>
+                <a:latin typeface="Calibri"/>
+              </a:rPr>
+              <a:t>chart.js &amp; react-chartjs-2: </a:t>
+            </a:r>
+            <a:r>
+              <a:rPr sz="1300">
+                <a:solidFill>
+                  <a:srgbClr val="334155"/>
+                </a:solidFill>
+                <a:latin typeface="Calibri"/>
+              </a:rPr>
+              <a:t>Randarea eficientă pe Canvas a graficelor interactive de tip radar și linie.</a:t>
+            </a:r>
+          </a:p>
+          <a:p>
+            <a:pPr lvl="1">
+              <a:spcAft>
+                <a:spcPts val="400"/>
+              </a:spcAft>
+            </a:pPr>
+            <a:r>
+              <a:rPr b="1" sz="1300">
+                <a:solidFill>
+                  <a:srgbClr val="334155"/>
+                </a:solidFill>
+                <a:latin typeface="Calibri"/>
+              </a:rPr>
+              <a:t>@vladmandic/face-api: </a:t>
+            </a:r>
+            <a:r>
+              <a:rPr sz="1300">
+                <a:solidFill>
+                  <a:srgbClr val="334155"/>
+                </a:solidFill>
+                <a:latin typeface="Calibri"/>
+              </a:rPr>
+              <a:t>Pachetul npm ce conține modulele pre-antrenate TensorFlow.js utilizate direct.</a:t>
+            </a:r>
+          </a:p>
+          <a:p>
+            <a:pPr>
+              <a:spcAft>
+                <a:spcPts val="800"/>
+              </a:spcAft>
+            </a:pPr>
+            <a:r>
+              <a:rPr b="1" sz="1500">
+                <a:solidFill>
+                  <a:srgbClr val="1E293B"/>
+                </a:solidFill>
+                <a:latin typeface="Calibri"/>
+              </a:rPr>
+              <a:t>Dependențe Principale Backend (Python &amp; pip): </a:t>
+            </a:r>
+            <a:r>
+              <a:rPr sz="1400">
+                <a:solidFill>
+                  <a:srgbClr val="1E293B"/>
+                </a:solidFill>
+                <a:latin typeface="Calibri"/>
+              </a:rPr>
+              <a:t>Mediu izolat virtual (venv) în Python 3.10+:</a:t>
+            </a:r>
+          </a:p>
+          <a:p>
+            <a:pPr lvl="1">
+              <a:spcAft>
+                <a:spcPts val="400"/>
+              </a:spcAft>
+            </a:pPr>
+            <a:r>
+              <a:rPr b="1" sz="1300">
+                <a:solidFill>
+                  <a:srgbClr val="334155"/>
+                </a:solidFill>
+                <a:latin typeface="Calibri"/>
+              </a:rPr>
+              <a:t>Flask-CORS: </a:t>
+            </a:r>
+            <a:r>
+              <a:rPr sz="1300">
+                <a:solidFill>
+                  <a:srgbClr val="334155"/>
+                </a:solidFill>
+                <a:latin typeface="Calibri"/>
+              </a:rPr>
+              <a:t>Permite schimbul de resurse între porturi diferite (5173 și 5000) și restricționează accesul neautorizat.</a:t>
+            </a:r>
+          </a:p>
+          <a:p>
+            <a:pPr lvl="1">
+              <a:spcAft>
+                <a:spcPts val="400"/>
+              </a:spcAft>
+            </a:pPr>
+            <a:r>
+              <a:rPr b="1" sz="1300">
+                <a:solidFill>
+                  <a:srgbClr val="334155"/>
+                </a:solidFill>
+                <a:latin typeface="Calibri"/>
+              </a:rPr>
+              <a:t>groq: </a:t>
+            </a:r>
+            <a:r>
+              <a:rPr sz="1300">
+                <a:solidFill>
+                  <a:srgbClr val="334155"/>
+                </a:solidFill>
+                <a:latin typeface="Calibri"/>
+              </a:rPr>
+              <a:t>Interfața de viteză ultra-ridicată cu LPU Cloud pentru modelele Whisper și Llama.</a:t>
+            </a:r>
+          </a:p>
+          <a:p>
+            <a:pPr lvl="1">
+              <a:spcAft>
+                <a:spcPts val="400"/>
+              </a:spcAft>
+            </a:pPr>
+            <a:r>
+              <a:rPr b="1" sz="1300">
+                <a:solidFill>
+                  <a:srgbClr val="334155"/>
+                </a:solidFill>
+                <a:latin typeface="Calibri"/>
+              </a:rPr>
+              <a:t>pytesseract &amp; Pillow (PIL): </a:t>
+            </a:r>
+            <a:r>
+              <a:rPr sz="1300">
+                <a:solidFill>
+                  <a:srgbClr val="334155"/>
+                </a:solidFill>
+                <a:latin typeface="Calibri"/>
+              </a:rPr>
+              <a:t>Transpunerea imaginilor de text încărcate de utilizator în text brut prin apelul binarului local tesseract.exe.</a:t>
+            </a:r>
+          </a:p>
+          <a:p>
+            <a:pPr>
+              <a:spcAft>
+                <a:spcPts val="800"/>
+              </a:spcAft>
+            </a:pPr>
+            <a:r>
+              <a:rPr b="1" sz="1500">
+                <a:solidFill>
+                  <a:srgbClr val="1E293B"/>
+                </a:solidFill>
+                <a:latin typeface="Calibri"/>
+              </a:rPr>
+              <a:t>Configurare prin Variabile de Mediu (.env): </a:t>
+            </a:r>
+            <a:r>
+              <a:rPr sz="1400">
+                <a:solidFill>
+                  <a:srgbClr val="1E293B"/>
+                </a:solidFill>
+                <a:latin typeface="Calibri"/>
+              </a:rPr>
+              <a:t>Fiecare instanță citește dinamic configurarea locală:</a:t>
+            </a:r>
+          </a:p>
+          <a:p>
+            <a:pPr lvl="1">
+              <a:spcAft>
+                <a:spcPts val="400"/>
+              </a:spcAft>
+            </a:pPr>
+            <a:r>
+              <a:rPr b="1" sz="1300">
+                <a:solidFill>
+                  <a:srgbClr val="334155"/>
+                </a:solidFill>
+                <a:latin typeface="Calibri"/>
+              </a:rPr>
+              <a:t>GROQ_API_KEY: </a:t>
+            </a:r>
+            <a:r>
+              <a:rPr sz="1300">
+                <a:solidFill>
+                  <a:srgbClr val="334155"/>
+                </a:solidFill>
+                <a:latin typeface="Calibri"/>
+              </a:rPr>
+              <a:t>Cheia de autentificare secretă la serviciul Groq Cloud.</a:t>
+            </a:r>
+          </a:p>
+          <a:p>
+            <a:pPr lvl="1">
+              <a:spcAft>
+                <a:spcPts val="400"/>
+              </a:spcAft>
+            </a:pPr>
+            <a:r>
+              <a:rPr b="1" sz="1300">
+                <a:solidFill>
+                  <a:srgbClr val="334155"/>
+                </a:solidFill>
+                <a:latin typeface="Calibri"/>
+              </a:rPr>
+              <a:t>TESSERACT_CMD: </a:t>
+            </a:r>
+            <a:r>
+              <a:rPr sz="1300">
+                <a:solidFill>
+                  <a:srgbClr val="334155"/>
+                </a:solidFill>
+                <a:latin typeface="Calibri"/>
+              </a:rPr>
+              <a:t>Calea fizică de pe sistemul gazdă spre executabilul local Tesseract OCR (implicit C:\Program Files\Tesseract-OCR\tesseract.exe).</a:t>
+            </a:r>
+          </a:p>
+        </p:txBody>
+      </p:sp>
+    </p:spTree>
+  </p:cSld>
+  <p:clrMapOvr>
+    <a:masterClrMapping/>
+  </p:clrMapOvr>
+</p:sld>
+</file>
+
+<file path=ppt/slides/slide13.xml><?xml version="1.0" encoding="utf-8"?>
+<p:sld xmlns:a="http://schemas.openxmlformats.org/drawingml/2006/main" xmlns:p="http://schemas.openxmlformats.org/presentationml/2006/main" xmlns:r="http://schemas.openxmlformats.org/officeDocument/2006/relationships">
+  <p:cSld>
+    <p:bg>
+      <p:bgPr>
+        <a:solidFill>
+          <a:srgbClr val="FFFFFF"/>
+        </a:solidFill>
+        <a:effectLst/>
+      </p:bgPr>
+    </p:bg>
+    <p:spTree>
+      <p:nvGrpSpPr>
+        <p:cNvPr id="1" name=""/>
+        <p:cNvGrpSpPr/>
+        <p:nvPr/>
+      </p:nvGrpSpPr>
+      <p:grpSpPr/>
+      <p:sp>
+        <p:nvSpPr>
+          <p:cNvPr id="2" name="TextBox 1"/>
+          <p:cNvSpPr txBox="1"/>
+          <p:nvPr/>
+        </p:nvSpPr>
+        <p:spPr>
+          <a:xfrm>
+            <a:off x="685800" y="365760"/>
+            <a:ext cx="10817352" cy="731520"/>
+          </a:xfrm>
+          <a:prstGeom prst="rect">
+            <a:avLst/>
+          </a:prstGeom>
+          <a:noFill/>
+        </p:spPr>
+        <p:txBody>
+          <a:bodyPr wrap="square" tIns="0" lIns="0">
+            <a:spAutoFit/>
+          </a:bodyPr>
+          <a:lstStyle/>
+          <a:p>
+            <a:pPr>
+              <a:defRPr sz="2200" b="1">
+                <a:solidFill>
+                  <a:srgbClr val="0F2043"/>
+                </a:solidFill>
+                <a:latin typeface="Arial"/>
+              </a:defRPr>
+            </a:pPr>
+            <a:r>
+              <a:t>DEMONSTRAȚIE PRACTICĂ (RULARE ÎN TIMP REAL)</a:t>
+            </a:r>
+          </a:p>
+        </p:txBody>
+      </p:sp>
+      <p:sp>
+        <p:nvSpPr>
+          <p:cNvPr id="3" name="TextBox 2"/>
+          <p:cNvSpPr txBox="1"/>
+          <p:nvPr/>
+        </p:nvSpPr>
+        <p:spPr>
+          <a:xfrm>
+            <a:off x="685800" y="1097280"/>
+            <a:ext cx="10817352" cy="548640"/>
+          </a:xfrm>
+          <a:prstGeom prst="rect">
+            <a:avLst/>
+          </a:prstGeom>
+          <a:noFill/>
+        </p:spPr>
+        <p:txBody>
+          <a:bodyPr wrap="square" tIns="0" lIns="0">
+            <a:spAutoFit/>
+          </a:bodyPr>
+          <a:lstStyle/>
+          <a:p>
+            <a:pPr>
+              <a:defRPr sz="1400">
+                <a:solidFill>
+                  <a:srgbClr val="334155"/>
+                </a:solidFill>
+                <a:latin typeface="Calibri"/>
+              </a:defRPr>
+            </a:pPr>
+            <a:r>
+              <a:t>Prezentarea înregistrată a interfețelor active de text (sarcasm/carantină), expresii faciale (Face-API/Vision) și analiză vocală (DSP).</a:t>
+            </a:r>
+          </a:p>
+        </p:txBody>
+      </p:sp>
+    </p:spTree>
+  </p:cSld>
+  <p:clrMapOvr>
+    <a:masterClrMapping/>
+  </p:clrMapOvr>
+</p:sld>
+</file>
+
+<file path=ppt/slides/slide14.xml><?xml version="1.0" encoding="utf-8"?>
+<p:sld xmlns:a="http://schemas.openxmlformats.org/drawingml/2006/main" xmlns:p="http://schemas.openxmlformats.org/presentationml/2006/main" xmlns:r="http://schemas.openxmlformats.org/officeDocument/2006/relationships">
+  <p:cSld>
+    <p:bg>
+      <p:bgPr>
+        <a:solidFill>
+          <a:srgbClr val="FFFFFF"/>
+        </a:solidFill>
+        <a:effectLst/>
+      </p:bgPr>
+    </p:bg>
+    <p:spTree>
+      <p:nvGrpSpPr>
+        <p:cNvPr id="1" name=""/>
+        <p:cNvGrpSpPr/>
+        <p:nvPr/>
+      </p:nvGrpSpPr>
+      <p:grpSpPr/>
+      <p:sp>
+        <p:nvSpPr>
+          <p:cNvPr id="2" name="TextBox 1"/>
+          <p:cNvSpPr txBox="1"/>
+          <p:nvPr/>
+        </p:nvSpPr>
+        <p:spPr>
+          <a:xfrm>
+            <a:off x="685800" y="365760"/>
+            <a:ext cx="10817352" cy="731520"/>
+          </a:xfrm>
+          <a:prstGeom prst="rect">
+            <a:avLst/>
+          </a:prstGeom>
+          <a:noFill/>
+        </p:spPr>
+        <p:txBody>
+          <a:bodyPr wrap="square" tIns="0" lIns="0">
+            <a:spAutoFit/>
+          </a:bodyPr>
+          <a:lstStyle/>
+          <a:p>
+            <a:pPr>
+              <a:defRPr sz="2200" b="1">
+                <a:solidFill>
+                  <a:srgbClr val="0F2043"/>
+                </a:solidFill>
+                <a:latin typeface="Arial"/>
+              </a:defRPr>
+            </a:pPr>
+            <a:r>
+              <a:t>Concluzii și Direcții de Dezvoltare Viitoare</a:t>
+            </a:r>
+          </a:p>
+        </p:txBody>
+      </p:sp>
+      <p:sp>
+        <p:nvSpPr>
+          <p:cNvPr id="3" name="TextBox 2"/>
+          <p:cNvSpPr txBox="1"/>
+          <p:nvPr/>
+        </p:nvSpPr>
+        <p:spPr>
+          <a:xfrm>
+            <a:off x="685800" y="1097280"/>
+            <a:ext cx="10817352" cy="5303520"/>
+          </a:xfrm>
+          <a:prstGeom prst="rect">
+            <a:avLst/>
+          </a:prstGeom>
+          <a:noFill/>
+        </p:spPr>
+        <p:txBody>
+          <a:bodyPr wrap="square" tIns="0" lIns="0">
+            <a:spAutoFit/>
+          </a:bodyPr>
+          <a:lstStyle/>
+          <a:p>
+            <a:pPr>
+              <a:spcAft>
+                <a:spcPts val="800"/>
+              </a:spcAft>
+            </a:pPr>
+            <a:r>
+              <a:rPr b="1" sz="1500">
+                <a:solidFill>
+                  <a:srgbClr val="1E293B"/>
+                </a:solidFill>
+                <a:latin typeface="Calibri"/>
+              </a:rPr>
               <a:t>Concluzii Teoretice și Practice: </a:t>
             </a:r>
             <a:r>
@@ -3663,7 +4409,7 @@
                 </a:solidFill>
                 <a:latin typeface="Calibri"/>
               </a:rPr>
-              <a:t>Platforma Anchor demonstrează că fuziunea multimodală acoperă deficiențele evaluărilor idividuale, oferind o precizie ridicată în screening-ul preliminar.</a:t>
+              <a:t>Platforma Anchor demonstrează că fuziunea multimodală acoperă deficiențele evaluărilor individuale, oferind o precizie ridicată în screening-ul preliminar.</a:t>
             </a:r>
           </a:p>
           <a:p>
@@ -4445,7 +5191,7 @@
               </a:defRPr>
             </a:pPr>
             <a:r>
-              <a:t>Modulul de Analiză Text (Semantică &amp; LLM)</a:t>
+              <a:t>Rute API și Comunicare CORS</a:t>
             </a:r>
           </a:p>
         </p:txBody>
@@ -4484,7 +5230,7 @@
                 </a:solidFill>
                 <a:latin typeface="Calibri"/>
               </a:rPr>
-              <a:t>Preprocesare și Extragere Context Local: </a:t>
+              <a:t>Separarea Porturilor: </a:t>
             </a:r>
             <a:r>
               <a:rPr sz="1400">
@@ -4493,7 +5239,32 @@
                 </a:solidFill>
                 <a:latin typeface="Calibri"/>
               </a:rPr>
-              <a:t>Filtrare locală a textului din frontend înainte de trimiterea la server pentru identificarea anomaliilor structurale.</a:t>
+              <a:t>Frontend-ul (React 19) rulează pe portul 5173, iar Backend-ul (Flask) pe portul 5000. Schimbul de date este asigurat prin CORS (Cross-Origin Resource Sharing).</a:t>
+            </a:r>
+          </a:p>
+          <a:p>
+            <a:pPr>
+              <a:spcAft>
+                <a:spcPts val="800"/>
+              </a:spcAft>
+            </a:pPr>
+            <a:r>
+              <a:rPr b="1" sz="1500">
+                <a:solidFill>
+                  <a:srgbClr val="1E293B"/>
+                </a:solidFill>
+                <a:latin typeface="Calibri"/>
+              </a:rPr>
+              <a:t>Rute HTTP POST Principale (Flask API în app.py): </a:t>
+            </a:r>
+            <a:r>
+              <a:rPr sz="1400">
+                <a:solidFill>
+                  <a:srgbClr val="1E293B"/>
+                </a:solidFill>
+                <a:latin typeface="Calibri"/>
+              </a:rPr>
+              <a:t>Cele patru endpoint-uri de analiză folosite de client:</a:t>
             </a:r>
           </a:p>
           <a:p>
@@ -4509,7 +5280,7 @@
                 </a:solidFill>
                 <a:latin typeface="Calibri"/>
               </a:rPr>
-              <a:t>Euristici locale: </a:t>
+              <a:t>POST /analyze-text: </a:t>
             </a:r>
             <a:r>
               <a:rPr sz="1300">
@@ -4518,7 +5289,7 @@
                 </a:solidFill>
                 <a:latin typeface="Calibri"/>
               </a:rPr>
-              <a:t>Analiza lexicală automată pentru sarcasm, majuscule excesive (indicator de stres) și disonanță cognitivă.</a:t>
+              <a:t>Trimite mesajul text introdus de utilizator pentru verificare semantică. Returnează diagnosticul clinic și feedback-ul empatic.</a:t>
             </a:r>
           </a:p>
           <a:p>
@@ -4534,7 +5305,7 @@
                 </a:solidFill>
                 <a:latin typeface="Calibri"/>
               </a:rPr>
-              <a:t>Context temporal: </a:t>
+              <a:t>POST /analyze-face: </a:t>
             </a:r>
             <a:r>
               <a:rPr sz="1300">
@@ -4543,7 +5314,57 @@
                 </a:solidFill>
                 <a:latin typeface="Calibri"/>
               </a:rPr>
-              <a:t>Extragerea automată a istoricului recent (ultimele 3 mesaje) și extins (ultimele 10 intrări) din SQLite.</a:t>
+              <a:t>Trimite imaginea de selfie (Base64 JPEG) capturată din webcam și coordonatele locale. Returnează expresiile calibrate și observațiile Groq Vision.</a:t>
+            </a:r>
+          </a:p>
+          <a:p>
+            <a:pPr lvl="1">
+              <a:spcAft>
+                <a:spcPts val="400"/>
+              </a:spcAft>
+            </a:pPr>
+            <a:r>
+              <a:rPr b="1" sz="1300">
+                <a:solidFill>
+                  <a:srgbClr val="334155"/>
+                </a:solidFill>
+                <a:latin typeface="Calibri"/>
+              </a:rPr>
+              <a:t>POST /analyze-voice: </a:t>
+            </a:r>
+            <a:r>
+              <a:rPr sz="1300">
+                <a:solidFill>
+                  <a:srgbClr val="334155"/>
+                </a:solidFill>
+                <a:latin typeface="Calibri"/>
+              </a:rPr>
+              <a:t>Trimite înregistrarea audio (Base64 WAV). Returnează transcrierea text, trăsăturile acustice (Tempo, ZCR) și scorul vocal agregat.</a:t>
+            </a:r>
+          </a:p>
+          <a:p>
+            <a:pPr lvl="1">
+              <a:spcAft>
+                <a:spcPts val="400"/>
+              </a:spcAft>
+            </a:pPr>
+            <a:r>
+              <a:rPr b="1" sz="1300">
+                <a:solidFill>
+                  <a:srgbClr val="334155"/>
+                </a:solidFill>
+                <a:latin typeface="Calibri"/>
+              </a:rPr>
+              <a:t>POST /analyze-multimodal: </a:t>
+            </a:r>
+            <a:r>
+              <a:rPr sz="1300">
+                <a:solidFill>
+                  <a:srgbClr val="334155"/>
+                </a:solidFill>
+                <a:latin typeface="Calibri"/>
+              </a:rPr>
+              <a:t>Corelează evaluările text, voce și față pentru a genera scorul final integrat.</a:t>
             </a:r>
           </a:p>
           <a:p>
@@ -4559,7 +5380,7 @@
                 </a:solidFill>
                 <a:latin typeface="Calibri"/>
               </a:rPr>
-              <a:t>Analiză Semantică Avansată (Llama 3.3 70B Versatile): </a:t>
+              <a:t>Securizarea Datelor în Tranzit: </a:t>
             </a:r>
             <a:r>
               <a:rPr sz="1400">
@@ -4568,107 +5389,7 @@
                 </a:solidFill>
                 <a:latin typeface="Calibri"/>
               </a:rPr>
-              <a:t>Integrarea API-ului Groq LPU cu format de răspuns JSON garantat:</a:t>
-            </a:r>
-          </a:p>
-          <a:p>
-            <a:pPr lvl="1">
-              <a:spcAft>
-                <a:spcPts val="400"/>
-              </a:spcAft>
-            </a:pPr>
-            <a:r>
-              <a:rPr b="1" sz="1300">
-                <a:solidFill>
-                  <a:srgbClr val="334155"/>
-                </a:solidFill>
-                <a:latin typeface="Calibri"/>
-              </a:rPr>
-              <a:t>JSON Schema rigid: </a:t>
-            </a:r>
-            <a:r>
-              <a:rPr sz="1300">
-                <a:solidFill>
-                  <a:srgbClr val="334155"/>
-                </a:solidFill>
-                <a:latin typeface="Calibri"/>
-              </a:rPr>
-              <a:t>Forțează modelul să returneze doar indicatori clinici binari (idee_adio, plan_iminent, depresie_cronica, mascare) și raționament clinic, prevenind halucinațiile textuale.</a:t>
-            </a:r>
-          </a:p>
-          <a:p>
-            <a:pPr>
-              <a:spcAft>
-                <a:spcPts val="800"/>
-              </a:spcAft>
-            </a:pPr>
-            <a:r>
-              <a:rPr b="1" sz="1500">
-                <a:solidFill>
-                  <a:srgbClr val="1E293B"/>
-                </a:solidFill>
-                <a:latin typeface="Calibri"/>
-              </a:rPr>
-              <a:t>Modelul de Scoring Clinic: </a:t>
-            </a:r>
-            <a:r>
-              <a:rPr sz="1400">
-                <a:solidFill>
-                  <a:srgbClr val="1E293B"/>
-                </a:solidFill>
-                <a:latin typeface="Calibri"/>
-              </a:rPr>
-              <a:t>Procesarea răspunsului JSON în serverul Flask:</a:t>
-            </a:r>
-          </a:p>
-          <a:p>
-            <a:pPr lvl="1">
-              <a:spcAft>
-                <a:spcPts val="400"/>
-              </a:spcAft>
-            </a:pPr>
-            <a:r>
-              <a:rPr b="1" sz="1300">
-                <a:solidFill>
-                  <a:srgbClr val="334155"/>
-                </a:solidFill>
-                <a:latin typeface="Calibri"/>
-              </a:rPr>
-              <a:t>Zone de risc: </a:t>
-            </a:r>
-            <a:r>
-              <a:rPr sz="1300">
-                <a:solidFill>
-                  <a:srgbClr val="334155"/>
-                </a:solidFill>
-                <a:latin typeface="Calibri"/>
-              </a:rPr>
-              <a:t>Scăzut (0-30%), Mediu (30-70%), Critic (70-100%).</a:t>
-            </a:r>
-          </a:p>
-          <a:p>
-            <a:pPr lvl="1">
-              <a:spcAft>
-                <a:spcPts val="400"/>
-              </a:spcAft>
-            </a:pPr>
-            <a:r>
-              <a:rPr b="1" sz="1300">
-                <a:solidFill>
-                  <a:srgbClr val="334155"/>
-                </a:solidFill>
-                <a:latin typeface="Calibri"/>
-              </a:rPr>
-              <a:t>Plafonare și corecții: </a:t>
-            </a:r>
-            <a:r>
-              <a:rPr sz="1300">
-                <a:solidFill>
-                  <a:srgbClr val="334155"/>
-                </a:solidFill>
-                <a:latin typeface="Calibri"/>
-              </a:rPr>
-              <a:t>Forțarea scorului în intervale specifice în funcție de markerii depistați (ex: minim 92% în caz de ideație sau arme).</a:t>
+              <a:t>Transferul fluxurilor de date mari (imagini și fișiere audio) se realizează securizat sub formă de șiruri de caractere codificate Base64 în corpul JSON-ului HTTP POST, fiind decodificate în bytes direct în RAM-ul serverului Flask.</a:t>
             </a:r>
           </a:p>
         </p:txBody>
@@ -4730,7 +5451,7 @@
               </a:defRPr>
             </a:pPr>
             <a:r>
-              <a:t>Analiza Facială I - Detecție Locală cu Face-API.js</a:t>
+              <a:t>Modulul de Analiză Text (Semantică &amp; LLM)</a:t>
             </a:r>
           </a:p>
         </p:txBody>
@@ -4769,7 +5490,7 @@
                 </a:solidFill>
                 <a:latin typeface="Calibri"/>
               </a:rPr>
-              <a:t>Conceptul Client-Side Processing: </a:t>
+              <a:t>Preprocesare și Extragere Context Local: </a:t>
             </a:r>
             <a:r>
               <a:rPr sz="1400">
@@ -4778,7 +5499,57 @@
                 </a:solidFill>
                 <a:latin typeface="Calibri"/>
               </a:rPr>
-              <a:t>Calculul biometriei direct pe mașina utilizatorului protejează confidențialitatea (imaginile video brute nu părăsesc browserul).</a:t>
+              <a:t>Filtrare locală a textului din frontend înainte de trimiterea la server pentru identificarea anomaliilor structurale.</a:t>
+            </a:r>
+          </a:p>
+          <a:p>
+            <a:pPr lvl="1">
+              <a:spcAft>
+                <a:spcPts val="400"/>
+              </a:spcAft>
+            </a:pPr>
+            <a:r>
+              <a:rPr b="1" sz="1300">
+                <a:solidFill>
+                  <a:srgbClr val="334155"/>
+                </a:solidFill>
+                <a:latin typeface="Calibri"/>
+              </a:rPr>
+              <a:t>Euristici locale: </a:t>
+            </a:r>
+            <a:r>
+              <a:rPr sz="1300">
+                <a:solidFill>
+                  <a:srgbClr val="334155"/>
+                </a:solidFill>
+                <a:latin typeface="Calibri"/>
+              </a:rPr>
+              <a:t>Analiza lexicală automată pentru sarcasm, majuscule excesive (indicator de stres) și disonanță cognitivă.</a:t>
+            </a:r>
+          </a:p>
+          <a:p>
+            <a:pPr lvl="1">
+              <a:spcAft>
+                <a:spcPts val="400"/>
+              </a:spcAft>
+            </a:pPr>
+            <a:r>
+              <a:rPr b="1" sz="1300">
+                <a:solidFill>
+                  <a:srgbClr val="334155"/>
+                </a:solidFill>
+                <a:latin typeface="Calibri"/>
+              </a:rPr>
+              <a:t>Context temporal: </a:t>
+            </a:r>
+            <a:r>
+              <a:rPr sz="1300">
+                <a:solidFill>
+                  <a:srgbClr val="334155"/>
+                </a:solidFill>
+                <a:latin typeface="Calibri"/>
+              </a:rPr>
+              <a:t>Extragerea automată a istoricului recent (ultimele 3 mesaje) și extins (ultimele 10 intrări) din SQLite.</a:t>
             </a:r>
           </a:p>
           <a:p>
@@ -4794,7 +5565,7 @@
                 </a:solidFill>
                 <a:latin typeface="Calibri"/>
               </a:rPr>
-              <a:t>Modele Rulate în Browser (TensorFlow.js): </a:t>
+              <a:t>Analiză Semantică Avansată (Llama 3.3 70B Versatile): </a:t>
             </a:r>
             <a:r>
               <a:rPr sz="1400">
@@ -4803,7 +5574,7 @@
                 </a:solidFill>
                 <a:latin typeface="Calibri"/>
               </a:rPr>
-              <a:t>Sistemul utilizează două module rețele neuronale convoluționale (CNN) pre-antrenate:</a:t>
+              <a:t>Integrarea API-ului Groq LPU cu format de răspuns JSON garantat:</a:t>
             </a:r>
           </a:p>
           <a:p>
@@ -4819,7 +5590,7 @@
                 </a:solidFill>
                 <a:latin typeface="Calibri"/>
               </a:rPr>
-              <a:t>Tiny Face Detector: </a:t>
+              <a:t>JSON Schema rigid: </a:t>
             </a:r>
             <a:r>
               <a:rPr sz="1300">
@@ -4828,7 +5599,32 @@
                 </a:solidFill>
                 <a:latin typeface="Calibri"/>
               </a:rPr>
-              <a:t>Localizează fața, detectează limitele geometrice și proiectează un mesh facial dinamic, un cerc de boundary și un laser pulsatoriu la 30+ FPS.</a:t>
+              <a:t>Forțează modelul să returneze doar indicatori clinici binari (idee_adio, plan_iminent, depresie_cronica, mascare) și raționament clinic, prevenind halucinațiile textuale.</a:t>
+            </a:r>
+          </a:p>
+          <a:p>
+            <a:pPr>
+              <a:spcAft>
+                <a:spcPts val="800"/>
+              </a:spcAft>
+            </a:pPr>
+            <a:r>
+              <a:rPr b="1" sz="1500">
+                <a:solidFill>
+                  <a:srgbClr val="1E293B"/>
+                </a:solidFill>
+                <a:latin typeface="Calibri"/>
+              </a:rPr>
+              <a:t>Modelul de Scoring Clinic: </a:t>
+            </a:r>
+            <a:r>
+              <a:rPr sz="1400">
+                <a:solidFill>
+                  <a:srgbClr val="1E293B"/>
+                </a:solidFill>
+                <a:latin typeface="Calibri"/>
+              </a:rPr>
+              <a:t>Procesarea răspunsului JSON în serverul Flask:</a:t>
             </a:r>
           </a:p>
           <a:p>
@@ -4844,7 +5640,7 @@
                 </a:solidFill>
                 <a:latin typeface="Calibri"/>
               </a:rPr>
-              <a:t>Face Expression Net: </a:t>
+              <a:t>Zone de risc: </a:t>
             </a:r>
             <a:r>
               <a:rPr sz="1300">
@@ -4853,57 +5649,32 @@
                 </a:solidFill>
                 <a:latin typeface="Calibri"/>
               </a:rPr>
-              <a:t>Clasifică în timp real probabilitățile celor 7 expresii de bază: tristețe, fericire, furie, frică, neutralitate, dezgust, surpriză.</a:t>
-            </a:r>
-          </a:p>
-          <a:p>
-            <a:pPr>
-              <a:spcAft>
-                <a:spcPts val="800"/>
-              </a:spcAft>
-            </a:pPr>
-            <a:r>
-              <a:rPr b="1" sz="1500">
-                <a:solidFill>
-                  <a:srgbClr val="1E293B"/>
-                </a:solidFill>
-                <a:latin typeface="Calibri"/>
-              </a:rPr>
-              <a:t>Gestiunea camerei în React: </a:t>
-            </a:r>
-            <a:r>
-              <a:rPr sz="1400">
-                <a:solidFill>
-                  <a:srgbClr val="1E293B"/>
-                </a:solidFill>
-                <a:latin typeface="Calibri"/>
-              </a:rPr>
-              <a:t>Sincronizarea stabilă a camerei web și a canvas-ului suprapus, legând stream-ul media la elementele DOM imediat ce sunt disponibile.</a:t>
-            </a:r>
-          </a:p>
-          <a:p>
-            <a:pPr>
-              <a:spcAft>
-                <a:spcPts val="800"/>
-              </a:spcAft>
-            </a:pPr>
-            <a:r>
-              <a:rPr b="1" sz="1500">
-                <a:solidFill>
-                  <a:srgbClr val="1E293B"/>
-                </a:solidFill>
-                <a:latin typeface="Calibri"/>
-              </a:rPr>
-              <a:t>Calibrarea Sensibilității Locale: </a:t>
-            </a:r>
-            <a:r>
-              <a:rPr sz="1400">
-                <a:solidFill>
-                  <a:srgbClr val="1E293B"/>
-                </a:solidFill>
-                <a:latin typeface="Calibri"/>
-              </a:rPr>
-              <a:t>Ajustarea manuală a pragurilor de detectare pentru a capta micro-expresiile subtile (irritabilitate, furie, suprimarea fericirii) înaintea trimiterii către server.</a:t>
+              <a:t>Scăzut (0-30%), Mediu (30-70%), Critic (70-100%).</a:t>
+            </a:r>
+          </a:p>
+          <a:p>
+            <a:pPr lvl="1">
+              <a:spcAft>
+                <a:spcPts val="400"/>
+              </a:spcAft>
+            </a:pPr>
+            <a:r>
+              <a:rPr b="1" sz="1300">
+                <a:solidFill>
+                  <a:srgbClr val="334155"/>
+                </a:solidFill>
+                <a:latin typeface="Calibri"/>
+              </a:rPr>
+              <a:t>Plafonare și corecții: </a:t>
+            </a:r>
+            <a:r>
+              <a:rPr sz="1300">
+                <a:solidFill>
+                  <a:srgbClr val="334155"/>
+                </a:solidFill>
+                <a:latin typeface="Calibri"/>
+              </a:rPr>
+              <a:t>Forțarea scorului în intervale specifice în funcție de markerii depistați (ex: minim 92% în caz de ideație sau arme).</a:t>
             </a:r>
           </a:p>
         </p:txBody>
@@ -4965,7 +5736,7 @@
               </a:defRPr>
             </a:pPr>
             <a:r>
-              <a:t>Analiza Facială II - Calibrare și Groq Vision Override</a:t>
+              <a:t>Analiza Facială I - Detecție Locală cu Face-API.js</a:t>
             </a:r>
           </a:p>
         </p:txBody>
@@ -5004,7 +5775,7 @@
                 </a:solidFill>
                 <a:latin typeface="Calibri"/>
               </a:rPr>
-              <a:t>Algoritmi de Calibrare Clinică (face.py): </a:t>
+              <a:t>Conceptul Client-Side Processing: </a:t>
             </a:r>
             <a:r>
               <a:rPr sz="1400">
@@ -5013,7 +5784,32 @@
                 </a:solidFill>
                 <a:latin typeface="Calibri"/>
               </a:rPr>
-              <a:t>Corectarea probabilităților brute transmise de Face-API.js folosind ecuații liniare continue:</a:t>
+              <a:t>Calculul biometriei direct pe mașina utilizatorului protejează confidențialitatea (imaginile video brute nu părăsesc browserul).</a:t>
+            </a:r>
+          </a:p>
+          <a:p>
+            <a:pPr>
+              <a:spcAft>
+                <a:spcPts val="800"/>
+              </a:spcAft>
+            </a:pPr>
+            <a:r>
+              <a:rPr b="1" sz="1500">
+                <a:solidFill>
+                  <a:srgbClr val="1E293B"/>
+                </a:solidFill>
+                <a:latin typeface="Calibri"/>
+              </a:rPr>
+              <a:t>Modele Rulate în Browser (TensorFlow.js): </a:t>
+            </a:r>
+            <a:r>
+              <a:rPr sz="1400">
+                <a:solidFill>
+                  <a:srgbClr val="1E293B"/>
+                </a:solidFill>
+                <a:latin typeface="Calibri"/>
+              </a:rPr>
+              <a:t>Sistemul utilizează două module rețele neuronale convoluționale (CNN) pre-antrenate:</a:t>
             </a:r>
           </a:p>
           <a:p>
@@ -5029,7 +5825,7 @@
                 </a:solidFill>
                 <a:latin typeface="Calibri"/>
               </a:rPr>
-              <a:t>Indicatorul de Anhedonie: </a:t>
+              <a:t>Tiny Face Detector: </a:t>
             </a:r>
             <a:r>
               <a:rPr sz="1300">
@@ -5038,7 +5834,7 @@
                 </a:solidFill>
                 <a:latin typeface="Calibri"/>
               </a:rPr>
-              <a:t>anhedonia_score = max(0, 100 - happy_score * 1.5). Valoarea este maximă la absența completă a zâmbetului.</a:t>
+              <a:t>Localizează fața, detectează limitele geometrice și proiectează un mesh facial dinamic, un cerc de boundary și un laser pulsatoriu la 30+ FPS.</a:t>
             </a:r>
           </a:p>
           <a:p>
@@ -5054,7 +5850,7 @@
                 </a:solidFill>
                 <a:latin typeface="Calibri"/>
               </a:rPr>
-              <a:t>Formula Scorului Brut: </a:t>
+              <a:t>Face Expression Net: </a:t>
             </a:r>
             <a:r>
               <a:rPr sz="1300">
@@ -5063,32 +5859,7 @@
                 </a:solidFill>
                 <a:latin typeface="Calibri"/>
               </a:rPr>
-              <a:t>sadness * 0.50 + anhedonia * 0.30 + anxiety * 0.20 + irritability * 0.10 + flat_affect * 0.10.</a:t>
-            </a:r>
-          </a:p>
-          <a:p>
-            <a:pPr lvl="1">
-              <a:spcAft>
-                <a:spcPts val="400"/>
-              </a:spcAft>
-            </a:pPr>
-            <a:r>
-              <a:rPr b="1" sz="1300">
-                <a:solidFill>
-                  <a:srgbClr val="334155"/>
-                </a:solidFill>
-                <a:latin typeface="Calibri"/>
-              </a:rPr>
-              <a:t>Suprimarea Activă a Fericirii: </a:t>
-            </a:r>
-            <a:r>
-              <a:rPr sz="1300">
-                <a:solidFill>
-                  <a:srgbClr val="334155"/>
-                </a:solidFill>
-                <a:latin typeface="Calibri"/>
-              </a:rPr>
-              <a:t>happiness_suppressor = max(0, 1.0 - happy_score / 60.0). Un zâmbet autentic (&gt;60%) forțează scorul facial de depresie la 0%.</a:t>
+              <a:t>Clasifică în timp real probabilitățile celor 7 expresii de bază: tristețe, fericire, furie, frică, neutralitate, dezgust, surpriză.</a:t>
             </a:r>
           </a:p>
           <a:p>
@@ -5104,7 +5875,7 @@
                 </a:solidFill>
                 <a:latin typeface="Calibri"/>
               </a:rPr>
-              <a:t>Compensare Hibridă cu Groq Vision (Llama Scout 17B): </a:t>
+              <a:t>Gestiunea camerei în React: </a:t>
             </a:r>
             <a:r>
               <a:rPr sz="1400">
@@ -5113,82 +5884,32 @@
                 </a:solidFill>
                 <a:latin typeface="Calibri"/>
               </a:rPr>
-              <a:t>Rezolvarea limitărilor rețelelor locale din browser:</a:t>
-            </a:r>
-          </a:p>
-          <a:p>
-            <a:pPr lvl="1">
-              <a:spcAft>
-                <a:spcPts val="400"/>
-              </a:spcAft>
-            </a:pPr>
-            <a:r>
-              <a:rPr b="1" sz="1300">
-                <a:solidFill>
-                  <a:srgbClr val="334155"/>
-                </a:solidFill>
-                <a:latin typeface="Calibri"/>
-              </a:rPr>
-              <a:t>Limitări locale: </a:t>
-            </a:r>
-            <a:r>
-              <a:rPr sz="1300">
-                <a:solidFill>
-                  <a:srgbClr val="334155"/>
-                </a:solidFill>
-                <a:latin typeface="Calibri"/>
-              </a:rPr>
-              <a:t>Ochii închiși/plânși sau umbrele faciale sunt interpretate greșit ca stare neutră de modelele locale.</a:t>
-            </a:r>
-          </a:p>
-          <a:p>
-            <a:pPr lvl="1">
-              <a:spcAft>
-                <a:spcPts val="400"/>
-              </a:spcAft>
-            </a:pPr>
-            <a:r>
-              <a:rPr b="1" sz="1300">
-                <a:solidFill>
-                  <a:srgbClr val="334155"/>
-                </a:solidFill>
-                <a:latin typeface="Calibri"/>
-              </a:rPr>
-              <a:t>Groq Vision: </a:t>
-            </a:r>
-            <a:r>
-              <a:rPr sz="1300">
-                <a:solidFill>
-                  <a:srgbClr val="334155"/>
-                </a:solidFill>
-                <a:latin typeface="Calibri"/>
-              </a:rPr>
-              <a:t>Serverul trimite instantaneul la Llama Scout. Acesta analizează postura, ochii strânși și contextul, suprascriind scorurile brute din browser în caz de anomalie.</a:t>
-            </a:r>
-          </a:p>
-          <a:p>
-            <a:pPr lvl="1">
-              <a:spcAft>
-                <a:spcPts val="400"/>
-              </a:spcAft>
-            </a:pPr>
-            <a:r>
-              <a:rPr b="1" sz="1300">
-                <a:solidFill>
-                  <a:srgbClr val="334155"/>
-                </a:solidFill>
-                <a:latin typeface="Calibri"/>
-              </a:rPr>
-              <a:t>Detecție de Urgență: </a:t>
-            </a:r>
-            <a:r>
-              <a:rPr sz="1300">
-                <a:solidFill>
-                  <a:srgbClr val="334155"/>
-                </a:solidFill>
-                <a:latin typeface="Calibri"/>
-              </a:rPr>
-              <a:t>Identificarea obiectelor periculoase în cadru (cuțite, arme) ce indică pericole iminente pentru siguranța utilizatorului.</a:t>
+              <a:t>Sincronizarea stabilă a camerei web și a canvas-ului suprapus, legând stream-ul media la elementele DOM imediat ce sunt disponibile.</a:t>
+            </a:r>
+          </a:p>
+          <a:p>
+            <a:pPr>
+              <a:spcAft>
+                <a:spcPts val="800"/>
+              </a:spcAft>
+            </a:pPr>
+            <a:r>
+              <a:rPr b="1" sz="1500">
+                <a:solidFill>
+                  <a:srgbClr val="1E293B"/>
+                </a:solidFill>
+                <a:latin typeface="Calibri"/>
+              </a:rPr>
+              <a:t>Calibrarea Sensibilității Locale: </a:t>
+            </a:r>
+            <a:r>
+              <a:rPr sz="1400">
+                <a:solidFill>
+                  <a:srgbClr val="1E293B"/>
+                </a:solidFill>
+                <a:latin typeface="Calibri"/>
+              </a:rPr>
+              <a:t>Ajustarea manuală a pragurilor de detectare pentru a capta micro-expresiile subtile (irritabilitate, furie, suprimarea fericirii) înaintea trimiterii către server.</a:t>
             </a:r>
           </a:p>
         </p:txBody>
@@ -5250,7 +5971,7 @@
               </a:defRPr>
             </a:pPr>
             <a:r>
-              <a:t>Analiza Vocală - Transcriere și Procesare DSP</a:t>
+              <a:t>Analiza Facială II - Calibrare și Groq Vision Override</a:t>
             </a:r>
           </a:p>
         </p:txBody>
@@ -5289,7 +6010,7 @@
                 </a:solidFill>
                 <a:latin typeface="Calibri"/>
               </a:rPr>
-              <a:t>Captare și Transcriere Vocală (Groq Whisper-large-v3): </a:t>
+              <a:t>Algoritmi de Calibrare Clinică (face.py): </a:t>
             </a:r>
             <a:r>
               <a:rPr sz="1400">
@@ -5298,7 +6019,7 @@
                 </a:solidFill>
                 <a:latin typeface="Calibri"/>
               </a:rPr>
-              <a:t>Microfonul înregistrează sunetul în format WAV necomprimat, trimis ca Base64:</a:t>
+              <a:t>Corectarea probabilităților brute transmise de Face-API.js folosind ecuații liniare continue:</a:t>
             </a:r>
           </a:p>
           <a:p>
@@ -5314,7 +6035,7 @@
                 </a:solidFill>
                 <a:latin typeface="Calibri"/>
               </a:rPr>
-              <a:t>Auto-Language Detection: </a:t>
+              <a:t>Indicatorul de Anhedonie: </a:t>
             </a:r>
             <a:r>
               <a:rPr sz="1300">
@@ -5323,7 +6044,7 @@
                 </a:solidFill>
                 <a:latin typeface="Calibri"/>
               </a:rPr>
-              <a:t>Whisper detectează dinamic limba vorbită (română/engleză), prevenind erorile fonetice de transcriere.</a:t>
+              <a:t>anhedonia_score = max(0, 100 - happy_score * 1.5). Valoarea este maximă la absența completă a zâmbetului.</a:t>
             </a:r>
           </a:p>
           <a:p>
@@ -5339,7 +6060,7 @@
                 </a:solidFill>
                 <a:latin typeface="Calibri"/>
               </a:rPr>
-              <a:t>Integrare semantică: </a:t>
+              <a:t>Formula Scorului Brut: </a:t>
             </a:r>
             <a:r>
               <a:rPr sz="1300">
@@ -5348,7 +6069,32 @@
                 </a:solidFill>
                 <a:latin typeface="Calibri"/>
               </a:rPr>
-              <a:t>Textul transcris este analizat de Llama și integrat automat în istoricul text al bazei de date.</a:t>
+              <a:t>sadness * 0.50 + anhedonia * 0.30 + anxiety * 0.20 + irritability * 0.10 + flat_affect * 0.10.</a:t>
+            </a:r>
+          </a:p>
+          <a:p>
+            <a:pPr lvl="1">
+              <a:spcAft>
+                <a:spcPts val="400"/>
+              </a:spcAft>
+            </a:pPr>
+            <a:r>
+              <a:rPr b="1" sz="1300">
+                <a:solidFill>
+                  <a:srgbClr val="334155"/>
+                </a:solidFill>
+                <a:latin typeface="Calibri"/>
+              </a:rPr>
+              <a:t>Suprimarea Activă a Fericirii: </a:t>
+            </a:r>
+            <a:r>
+              <a:rPr sz="1300">
+                <a:solidFill>
+                  <a:srgbClr val="334155"/>
+                </a:solidFill>
+                <a:latin typeface="Calibri"/>
+              </a:rPr>
+              <a:t>happiness_suppressor = max(0, 1.0 - happy_score / 60.0). Un zâmbet autentic (&gt;60%) forțează scorul facial de depresie la 0%.</a:t>
             </a:r>
           </a:p>
           <a:p>
@@ -5364,7 +6110,7 @@
                 </a:solidFill>
                 <a:latin typeface="Calibri"/>
               </a:rPr>
-              <a:t>Procesarea Semnalelor Digitale (DSP) Hibridă (voice.py): </a:t>
+              <a:t>Compensare Hibridă cu Groq Vision (Llama Scout 17B): </a:t>
             </a:r>
             <a:r>
               <a:rPr sz="1400">
@@ -5373,7 +6119,7 @@
                 </a:solidFill>
                 <a:latin typeface="Calibri"/>
               </a:rPr>
-              <a:t>Extragerea trăsăturilor paralingvistice acustice din fișierul audio:</a:t>
+              <a:t>Rezolvarea limitărilor rețelelor locale din browser:</a:t>
             </a:r>
           </a:p>
           <a:p>
@@ -5389,7 +6135,7 @@
                 </a:solidFill>
                 <a:latin typeface="Calibri"/>
               </a:rPr>
-              <a:t>Librosa (Motor Principal): </a:t>
+              <a:t>Limitări locale: </a:t>
             </a:r>
             <a:r>
               <a:rPr sz="1300">
@@ -5398,7 +6144,7 @@
                 </a:solidFill>
                 <a:latin typeface="Calibri"/>
               </a:rPr>
-              <a:t>Calculează energia RMS, tempo-ul (BPM), rata trecerii prin zero (ZCR) și centroidul spectral.</a:t>
+              <a:t>Ochii închiși/plânși sau umbrele faciale sunt interpretate greșit ca stare neutră de modelele locale.</a:t>
             </a:r>
           </a:p>
           <a:p>
@@ -5414,7 +6160,7 @@
                 </a:solidFill>
                 <a:latin typeface="Calibri"/>
               </a:rPr>
-              <a:t>Wave + NumPy Fallback: </a:t>
+              <a:t>Groq Vision: </a:t>
             </a:r>
             <a:r>
               <a:rPr sz="1300">
@@ -5423,32 +6169,7 @@
                 </a:solidFill>
                 <a:latin typeface="Calibri"/>
               </a:rPr>
-              <a:t>Dacă Librosa lipsește pe sistemul gazdă, un parser proprietar citește antetul WAV și datele PCM. NumPy calculează energia medie și ZCR direct pe semnalul normalizat în intervalul [-1.0, 1.0].</a:t>
-            </a:r>
-          </a:p>
-          <a:p>
-            <a:pPr>
-              <a:spcAft>
-                <a:spcPts val="800"/>
-              </a:spcAft>
-            </a:pPr>
-            <a:r>
-              <a:rPr b="1" sz="1500">
-                <a:solidFill>
-                  <a:srgbClr val="1E293B"/>
-                </a:solidFill>
-                <a:latin typeface="Calibri"/>
-              </a:rPr>
-              <a:t>Indicatori de Depresie Vocală: </a:t>
-            </a:r>
-            <a:r>
-              <a:rPr sz="1400">
-                <a:solidFill>
-                  <a:srgbClr val="1E293B"/>
-                </a:solidFill>
-                <a:latin typeface="Calibri"/>
-              </a:rPr>
-              <a:t>Scoruri de risc calculate pe baza parametrilor:</a:t>
+              <a:t>Serverul trimite instantaneul la Llama Scout. Acesta analizează postura, ochii strânși și contextul, suprascriind scorurile brute din browser în caz de anomalie.</a:t>
             </a:r>
           </a:p>
           <a:p>
@@ -5464,7 +6185,7 @@
                 </a:solidFill>
                 <a:latin typeface="Calibri"/>
               </a:rPr>
-              <a:t>Energie redusă: </a:t>
+              <a:t>Detecție de Urgență: </a:t>
             </a:r>
             <a:r>
               <a:rPr sz="1300">
@@ -5473,57 +6194,7 @@
                 </a:solidFill>
                 <a:latin typeface="Calibri"/>
               </a:rPr>
-              <a:t>Corespondența clinică cu oboseala, vocalizarea plată și letargia.</a:t>
-            </a:r>
-          </a:p>
-          <a:p>
-            <a:pPr lvl="1">
-              <a:spcAft>
-                <a:spcPts val="400"/>
-              </a:spcAft>
-            </a:pPr>
-            <a:r>
-              <a:rPr b="1" sz="1300">
-                <a:solidFill>
-                  <a:srgbClr val="334155"/>
-                </a:solidFill>
-                <a:latin typeface="Calibri"/>
-              </a:rPr>
-              <a:t>Tempo scăzut: </a:t>
-            </a:r>
-            <a:r>
-              <a:rPr sz="1300">
-                <a:solidFill>
-                  <a:srgbClr val="334155"/>
-                </a:solidFill>
-                <a:latin typeface="Calibri"/>
-              </a:rPr>
-              <a:t>Indică retardul psihomotor și vorbirea extrem de lentă.</a:t>
-            </a:r>
-          </a:p>
-          <a:p>
-            <a:pPr lvl="1">
-              <a:spcAft>
-                <a:spcPts val="400"/>
-              </a:spcAft>
-            </a:pPr>
-            <a:r>
-              <a:rPr b="1" sz="1300">
-                <a:solidFill>
-                  <a:srgbClr val="334155"/>
-                </a:solidFill>
-                <a:latin typeface="Calibri"/>
-              </a:rPr>
-              <a:t>ZCR redus: </a:t>
-            </a:r>
-            <a:r>
-              <a:rPr sz="1300">
-                <a:solidFill>
-                  <a:srgbClr val="334155"/>
-                </a:solidFill>
-                <a:latin typeface="Calibri"/>
-              </a:rPr>
-              <a:t>Asociat cu vorbirea neclară, mormăită și lipsa de articulație clară.</a:t>
+              <a:t>Identificarea obiectelor periculoase în cadru (cuțite, arme) ce indică pericole iminente pentru siguranța utilizatorului.</a:t>
             </a:r>
           </a:p>
         </p:txBody>
@@ -5585,7 +6256,7 @@
               </a:defRPr>
             </a:pPr>
             <a:r>
-              <a:t>Fuziunea Multimodală și override-urile de siguranță</a:t>
+              <a:t>Analiza Vocală - Transcriere și Procesare DSP</a:t>
             </a:r>
           </a:p>
         </p:txBody>
@@ -5624,7 +6295,7 @@
                 </a:solidFill>
                 <a:latin typeface="Calibri"/>
               </a:rPr>
-              <a:t>Algoritmul de Fuziune Multimodală: </a:t>
+              <a:t>Captare și Transcriere Vocală (Groq Whisper-large-v3): </a:t>
             </a:r>
             <a:r>
               <a:rPr sz="1400">
@@ -5633,7 +6304,7 @@
                 </a:solidFill>
                 <a:latin typeface="Calibri"/>
               </a:rPr>
-              <a:t>Agregare la nivel de decizie (late fusion) folosind ponderi asimetrice:</a:t>
+              <a:t>Microfonul înregistrează sunetul în format WAV necomprimat, trimis ca Base64:</a:t>
             </a:r>
           </a:p>
           <a:p>
@@ -5649,7 +6320,7 @@
                 </a:solidFill>
                 <a:latin typeface="Calibri"/>
               </a:rPr>
-              <a:t>Formula generală: </a:t>
+              <a:t>Auto-Language Detection: </a:t>
             </a:r>
             <a:r>
               <a:rPr sz="1300">
@@ -5658,7 +6329,32 @@
                 </a:solidFill>
                 <a:latin typeface="Calibri"/>
               </a:rPr>
-              <a:t>Scor Combinat = (Scor Text * 0.50) + (Scor Voce * 0.25) + (Scor Față * 0.25).</a:t>
+              <a:t>Whisper detectează dinamic limba vorbită (română/engleză), prevenind erorile fonetice de transcriere.</a:t>
+            </a:r>
+          </a:p>
+          <a:p>
+            <a:pPr lvl="1">
+              <a:spcAft>
+                <a:spcPts val="400"/>
+              </a:spcAft>
+            </a:pPr>
+            <a:r>
+              <a:rPr b="1" sz="1300">
+                <a:solidFill>
+                  <a:srgbClr val="334155"/>
+                </a:solidFill>
+                <a:latin typeface="Calibri"/>
+              </a:rPr>
+              <a:t>Integrare semantică: </a:t>
+            </a:r>
+            <a:r>
+              <a:rPr sz="1300">
+                <a:solidFill>
+                  <a:srgbClr val="334155"/>
+                </a:solidFill>
+                <a:latin typeface="Calibri"/>
+              </a:rPr>
+              <a:t>Textul transcris este analizat de Llama și integrat automat în istoricul text al bazei de date.</a:t>
             </a:r>
           </a:p>
           <a:p>
@@ -5674,7 +6370,7 @@
                 </a:solidFill>
                 <a:latin typeface="Calibri"/>
               </a:rPr>
-              <a:t>Calculul Scorului de Încredere (Confidence Score): </a:t>
+              <a:t>Procesarea Semnalelor Digitale (DSP) Hibridă (voice.py): </a:t>
             </a:r>
             <a:r>
               <a:rPr sz="1400">
@@ -5683,7 +6379,7 @@
                 </a:solidFill>
                 <a:latin typeface="Calibri"/>
               </a:rPr>
-              <a:t>Evaluarea divergenței semnalelor clinice:</a:t>
+              <a:t>Extragerea trăsăturilor paralingvistice acustice din fișierul audio:</a:t>
             </a:r>
           </a:p>
           <a:p>
@@ -5699,7 +6395,7 @@
                 </a:solidFill>
                 <a:latin typeface="Calibri"/>
               </a:rPr>
-              <a:t>Formulă: </a:t>
+              <a:t>Librosa (Motor Principal): </a:t>
             </a:r>
             <a:r>
               <a:rPr sz="1300">
@@ -5708,7 +6404,7 @@
                 </a:solidFill>
                 <a:latin typeface="Calibri"/>
               </a:rPr>
-              <a:t>Divergență = max(|T-V|, |T-F|, |V-F|). Încrederea = 100 - Divergență.</a:t>
+              <a:t>Calculează energia RMS, tempo-ul (BPM), rata trecerii prin zero (ZCR) și centroidul spectral.</a:t>
             </a:r>
           </a:p>
           <a:p>
@@ -5724,7 +6420,7 @@
                 </a:solidFill>
                 <a:latin typeface="Calibri"/>
               </a:rPr>
-              <a:t>Utilitate clinică: </a:t>
+              <a:t>Wave + NumPy Fallback: </a:t>
             </a:r>
             <a:r>
               <a:rPr sz="1300">
@@ -5733,7 +6429,7 @@
                 </a:solidFill>
                 <a:latin typeface="Calibri"/>
               </a:rPr>
-              <a:t>O încredere mică semnalează disimularea (ex. text suicidal trimis cu o mimică zâmbitoare).</a:t>
+              <a:t>Dacă Librosa lipsește pe sistemul gazdă, un parser proprietar citește antetul WAV și datele PCM. NumPy calculează energia medie și ZCR direct pe semnalul normalizat în intervalul [-1.0, 1.0].</a:t>
             </a:r>
           </a:p>
           <a:p>
@@ -5749,7 +6445,7 @@
                 </a:solidFill>
                 <a:latin typeface="Calibri"/>
               </a:rPr>
-              <a:t>Override de Siguranță Clinică (Text Content Priority): </a:t>
+              <a:t>Indicatori de Depresie Vocală: </a:t>
             </a:r>
             <a:r>
               <a:rPr sz="1400">
@@ -5758,7 +6454,7 @@
                 </a:solidFill>
                 <a:latin typeface="Calibri"/>
               </a:rPr>
-              <a:t>Semantica prevalează întotdeauna în fața acusticii:</a:t>
+              <a:t>Scoruri de risc calculate pe baza parametrilor:</a:t>
             </a:r>
           </a:p>
           <a:p>
@@ -5774,7 +6470,7 @@
                 </a:solidFill>
                 <a:latin typeface="Calibri"/>
               </a:rPr>
-              <a:t>Logică: </a:t>
+              <a:t>Energie redusă: </a:t>
             </a:r>
             <a:r>
               <a:rPr sz="1300">
@@ -5783,32 +6479,7 @@
                 </a:solidFill>
                 <a:latin typeface="Calibri"/>
               </a:rPr>
-              <a:t>Dacă textul indică un risc ridicat (ex. fraze critice, auto-vătămare), scorul textului suprascrie scorul acustic. Previne situațiile în care planurile de suicid sunt rostite cu o voce artificial calmă.</a:t>
-            </a:r>
-          </a:p>
-          <a:p>
-            <a:pPr>
-              <a:spcAft>
-                <a:spcPts val="800"/>
-              </a:spcAft>
-            </a:pPr>
-            <a:r>
-              <a:rPr b="1" sz="1500">
-                <a:solidFill>
-                  <a:srgbClr val="1E293B"/>
-                </a:solidFill>
-                <a:latin typeface="Calibri"/>
-              </a:rPr>
-              <a:t>Algoritmul de Carantină (Viteză de variație): </a:t>
-            </a:r>
-            <a:r>
-              <a:rPr sz="1400">
-                <a:solidFill>
-                  <a:srgbClr val="1E293B"/>
-                </a:solidFill>
-                <a:latin typeface="Calibri"/>
-              </a:rPr>
-              <a:t>Protecție împotriva falselor îmbunătățiri:</a:t>
+              <a:t>Corespondența clinică cu oboseala, vocalizarea plată și letargia.</a:t>
             </a:r>
           </a:p>
           <a:p>
@@ -5824,7 +6495,7 @@
                 </a:solidFill>
                 <a:latin typeface="Calibri"/>
               </a:rPr>
-              <a:t>Logică: </a:t>
+              <a:t>Tempo scăzut: </a:t>
             </a:r>
             <a:r>
               <a:rPr sz="1300">
@@ -5833,7 +6504,32 @@
                 </a:solidFill>
                 <a:latin typeface="Calibri"/>
               </a:rPr>
-              <a:t>Dacă scorul anterior a fost critic (&gt;= 70%), scorul curent nu poate scădea cu mai mult de 15% pe mesaj. Împiedică închiderea evaluării de către un utilizator aflat în criză prin disimularea bruscă a stării.</a:t>
+              <a:t>Indică retardul psihomotor și vorbirea extrem de lentă.</a:t>
+            </a:r>
+          </a:p>
+          <a:p>
+            <a:pPr lvl="1">
+              <a:spcAft>
+                <a:spcPts val="400"/>
+              </a:spcAft>
+            </a:pPr>
+            <a:r>
+              <a:rPr b="1" sz="1300">
+                <a:solidFill>
+                  <a:srgbClr val="334155"/>
+                </a:solidFill>
+                <a:latin typeface="Calibri"/>
+              </a:rPr>
+              <a:t>ZCR redus: </a:t>
+            </a:r>
+            <a:r>
+              <a:rPr sz="1300">
+                <a:solidFill>
+                  <a:srgbClr val="334155"/>
+                </a:solidFill>
+                <a:latin typeface="Calibri"/>
+              </a:rPr>
+              <a:t>Asociat cu vorbirea neclară, mormăită și lipsa de articulație clară.</a:t>
             </a:r>
           </a:p>
         </p:txBody>
@@ -5895,7 +6591,7 @@
               </a:defRPr>
             </a:pPr>
             <a:r>
-              <a:t>Persistența Datelor, Securitate și Conformitate GDPR</a:t>
+              <a:t>Fuziunea Multimodală și override-urile de siguranță</a:t>
             </a:r>
           </a:p>
         </p:txBody>
@@ -5934,7 +6630,7 @@
                 </a:solidFill>
                 <a:latin typeface="Calibri"/>
               </a:rPr>
-              <a:t>Structura Bazei de Date (SQLite local): </a:t>
+              <a:t>Algoritmul de Fuziune Multimodală: </a:t>
             </a:r>
             <a:r>
               <a:rPr sz="1400">
@@ -5943,7 +6639,7 @@
                 </a:solidFill>
                 <a:latin typeface="Calibri"/>
               </a:rPr>
-              <a:t>Sistem de persistență minimalist într-un singur fișier (mindscan_history.db) cu 5 tabele relaționale:</a:t>
+              <a:t>Agregare la nivel de decizie (late fusion) folosind ponderi asimetrice:</a:t>
             </a:r>
           </a:p>
           <a:p>
@@ -5959,7 +6655,7 @@
                 </a:solidFill>
                 <a:latin typeface="Calibri"/>
               </a:rPr>
-              <a:t>chats: </a:t>
+              <a:t>Formula generală: </a:t>
             </a:r>
             <a:r>
               <a:rPr sz="1300">
@@ -5968,7 +6664,32 @@
                 </a:solidFill>
                 <a:latin typeface="Calibri"/>
               </a:rPr>
-              <a:t>Id-ul sesiunii, numele persoanei evaluate și timestamps.</a:t>
+              <a:t>Scor Combinat = (Scor Text * 0.50) + (Scor Voce * 0.25) + (Scor Față * 0.25).</a:t>
+            </a:r>
+          </a:p>
+          <a:p>
+            <a:pPr>
+              <a:spcAft>
+                <a:spcPts val="800"/>
+              </a:spcAft>
+            </a:pPr>
+            <a:r>
+              <a:rPr b="1" sz="1500">
+                <a:solidFill>
+                  <a:srgbClr val="1E293B"/>
+                </a:solidFill>
+                <a:latin typeface="Calibri"/>
+              </a:rPr>
+              <a:t>Calculul Scorului de Încredere (Confidence Score): </a:t>
+            </a:r>
+            <a:r>
+              <a:rPr sz="1400">
+                <a:solidFill>
+                  <a:srgbClr val="1E293B"/>
+                </a:solidFill>
+                <a:latin typeface="Calibri"/>
+              </a:rPr>
+              <a:t>Evaluarea divergenței semnalelor clinice:</a:t>
             </a:r>
           </a:p>
           <a:p>
@@ -5984,7 +6705,7 @@
                 </a:solidFill>
                 <a:latin typeface="Calibri"/>
               </a:rPr>
-              <a:t>analize: </a:t>
+              <a:t>Formulă: </a:t>
             </a:r>
             <a:r>
               <a:rPr sz="1300">
@@ -5993,7 +6714,7 @@
                 </a:solidFill>
                 <a:latin typeface="Calibri"/>
               </a:rPr>
-              <a:t>Istoricul text, scorurile semantice, raționamentul LLM și feedback-ul empatic.</a:t>
+              <a:t>Divergență = max(|T-V|, |T-F|, |V-F|). Încrederea = 100 - Divergență.</a:t>
             </a:r>
           </a:p>
           <a:p>
@@ -6009,7 +6730,7 @@
                 </a:solidFill>
                 <a:latin typeface="Calibri"/>
               </a:rPr>
-              <a:t>voice_analysis &amp; face_analysis: </a:t>
+              <a:t>Utilitate clinică: </a:t>
             </a:r>
             <a:r>
               <a:rPr sz="1300">
@@ -6018,7 +6739,32 @@
                 </a:solidFill>
                 <a:latin typeface="Calibri"/>
               </a:rPr>
-              <a:t>Transcrierea audio, parametrii biometrici brut și calea fișierelor pe disc.</a:t>
+              <a:t>O încredere mică semnalează disimularea (ex. text suicidal trimis cu o mimică zâmbitoare).</a:t>
+            </a:r>
+          </a:p>
+          <a:p>
+            <a:pPr>
+              <a:spcAft>
+                <a:spcPts val="800"/>
+              </a:spcAft>
+            </a:pPr>
+            <a:r>
+              <a:rPr b="1" sz="1500">
+                <a:solidFill>
+                  <a:srgbClr val="1E293B"/>
+                </a:solidFill>
+                <a:latin typeface="Calibri"/>
+              </a:rPr>
+              <a:t>Override de Siguranță Clinică (Text Content Priority): </a:t>
+            </a:r>
+            <a:r>
+              <a:rPr sz="1400">
+                <a:solidFill>
+                  <a:srgbClr val="1E293B"/>
+                </a:solidFill>
+                <a:latin typeface="Calibri"/>
+              </a:rPr>
+              <a:t>Semantica prevalează întotdeauna în fața acusticii:</a:t>
             </a:r>
           </a:p>
           <a:p>
@@ -6034,7 +6780,7 @@
                 </a:solidFill>
                 <a:latin typeface="Calibri"/>
               </a:rPr>
-              <a:t>multimodal_analysis: </a:t>
+              <a:t>Logică: </a:t>
             </a:r>
             <a:r>
               <a:rPr sz="1300">
@@ -6043,7 +6789,7 @@
                 </a:solidFill>
                 <a:latin typeface="Calibri"/>
               </a:rPr>
-              <a:t>Scorurile agregate finale și încrederea multimodală.</a:t>
+              <a:t>Dacă textul indică un risc ridicat (ex. fraze critice, auto-vătămare), scorul textului suprascrie scorul acustic. Previne situațiile în care planurile de suicid sunt rostite cu o voce artificial calmă.</a:t>
             </a:r>
           </a:p>
           <a:p>
@@ -6059,7 +6805,7 @@
                 </a:solidFill>
                 <a:latin typeface="Calibri"/>
               </a:rPr>
-              <a:t>Securitatea Bazelor de Date (SQL Injection): </a:t>
+              <a:t>Algoritmul de Carantină (Viteză de variație): </a:t>
             </a:r>
             <a:r>
               <a:rPr sz="1400">
@@ -6068,57 +6814,32 @@
                 </a:solidFill>
                 <a:latin typeface="Calibri"/>
               </a:rPr>
-              <a:t>Toate interogările folosesc interogări complet parametrizate (prepared statements cu placeholders '?'). Nicio intrare de la utilizator nu este concatenată direct în SQL.</a:t>
-            </a:r>
-          </a:p>
-          <a:p>
-            <a:pPr>
-              <a:spcAft>
-                <a:spcPts val="800"/>
-              </a:spcAft>
-            </a:pPr>
-            <a:r>
-              <a:rPr b="1" sz="1500">
-                <a:solidFill>
-                  <a:srgbClr val="1E293B"/>
-                </a:solidFill>
-                <a:latin typeface="Calibri"/>
-              </a:rPr>
-              <a:t>Gestiunea Concurenței: </a:t>
-            </a:r>
-            <a:r>
-              <a:rPr sz="1400">
-                <a:solidFill>
-                  <a:srgbClr val="1E293B"/>
-                </a:solidFill>
-                <a:latin typeface="Calibri"/>
-              </a:rPr>
-              <a:t>Configurarea unui timeout de 10.0 secunde pe conexiunea SQLite pentru a asigura scrieri concurente ordonate, fără blocarea bazei de date (database locked).</a:t>
-            </a:r>
-          </a:p>
-          <a:p>
-            <a:pPr>
-              <a:spcAft>
-                <a:spcPts val="800"/>
-              </a:spcAft>
-            </a:pPr>
-            <a:r>
-              <a:rPr b="1" sz="1500">
-                <a:solidFill>
-                  <a:srgbClr val="1E293B"/>
-                </a:solidFill>
-                <a:latin typeface="Calibri"/>
-              </a:rPr>
-              <a:t>Ștergerea Securizată (GDPR Compliance): </a:t>
-            </a:r>
-            <a:r>
-              <a:rPr sz="1400">
-                <a:solidFill>
-                  <a:srgbClr val="1E293B"/>
-                </a:solidFill>
-                <a:latin typeface="Calibri"/>
-              </a:rPr>
-              <a:t>La click pe 'Șterge Istoricul', serverul Flask identifică URL-urile din DB, șterge fizic fișierele binare (.wav și .jpg) din folderul uploads/ folosind os.remove(), apoi execută comanda DELETE din tabele.</a:t>
+              <a:t>Protecție împotriva falselor îmbunătățiri:</a:t>
+            </a:r>
+          </a:p>
+          <a:p>
+            <a:pPr lvl="1">
+              <a:spcAft>
+                <a:spcPts val="400"/>
+              </a:spcAft>
+            </a:pPr>
+            <a:r>
+              <a:rPr b="1" sz="1300">
+                <a:solidFill>
+                  <a:srgbClr val="334155"/>
+                </a:solidFill>
+                <a:latin typeface="Calibri"/>
+              </a:rPr>
+              <a:t>Logică: </a:t>
+            </a:r>
+            <a:r>
+              <a:rPr sz="1300">
+                <a:solidFill>
+                  <a:srgbClr val="334155"/>
+                </a:solidFill>
+                <a:latin typeface="Calibri"/>
+              </a:rPr>
+              <a:t>Dacă scorul anterior a fost critic (&gt;= 70%), scorul curent nu poate scădea cu mai mult de 15% pe mesaj. Împiedică închiderea evaluării de către un utilizator aflat în criză prin disimularea bruscă a stării.</a:t>
             </a:r>
           </a:p>
         </p:txBody>

</xml_diff>

<commit_message>
docs: add two theoretical and practical conclusions to Slide 14
</commit_message>
<xml_diff>
--- a/Prezentare_Licenta_Podean_Beniamin.pptx
+++ b/Prezentare_Licenta_Podean_Beniamin.pptx
@@ -4460,6 +4460,56 @@
                 <a:latin typeface="Calibri"/>
               </a:rPr>
               <a:t>Algoritmii DSP de fallback și interfețele hibride groq-vision garantează funcționarea în parametri optimi chiar și la conexiuni defectuoase.</a:t>
+            </a:r>
+          </a:p>
+          <a:p>
+            <a:pPr lvl="1">
+              <a:spcAft>
+                <a:spcPts val="400"/>
+              </a:spcAft>
+            </a:pPr>
+            <a:r>
+              <a:rPr b="1" sz="1300">
+                <a:solidFill>
+                  <a:srgbClr val="334155"/>
+                </a:solidFill>
+                <a:latin typeface="Calibri"/>
+              </a:rPr>
+              <a:t>Securitate clinică: </a:t>
+            </a:r>
+            <a:r>
+              <a:rPr sz="1300">
+                <a:solidFill>
+                  <a:srgbClr val="334155"/>
+                </a:solidFill>
+                <a:latin typeface="Calibri"/>
+              </a:rPr>
+              <a:t>Algoritmul de carantină împiedică disimularea bruscă a stărilor de risc, forțând menținerea vigilenței clinice.</a:t>
+            </a:r>
+          </a:p>
+          <a:p>
+            <a:pPr lvl="1">
+              <a:spcAft>
+                <a:spcPts val="400"/>
+              </a:spcAft>
+            </a:pPr>
+            <a:r>
+              <a:rPr b="1" sz="1300">
+                <a:solidFill>
+                  <a:srgbClr val="334155"/>
+                </a:solidFill>
+                <a:latin typeface="Calibri"/>
+              </a:rPr>
+              <a:t>Optimizare resurse: </a:t>
+            </a:r>
+            <a:r>
+              <a:rPr sz="1300">
+                <a:solidFill>
+                  <a:srgbClr val="334155"/>
+                </a:solidFill>
+                <a:latin typeface="Calibri"/>
+              </a:rPr>
+              <a:t>Procesarea locală a imaginilor prin Face-API.js reduce încărcarea serverului și minimizează lățimea de bandă consumată.</a:t>
             </a:r>
           </a:p>
           <a:p>

</xml_diff>

<commit_message>
docs: enrich Slide 14 with deep clinical-technical breakthroughs
</commit_message>
<xml_diff>
--- a/Prezentare_Licenta_Podean_Beniamin.pptx
+++ b/Prezentare_Licenta_Podean_Beniamin.pptx
@@ -4425,7 +4425,7 @@
                 </a:solidFill>
                 <a:latin typeface="Calibri"/>
               </a:rPr>
-              <a:t>Funcționare locală: </a:t>
+              <a:t>Detecția incongruenței afective (Disimularea): </a:t>
             </a:r>
             <a:r>
               <a:rPr sz="1300">
@@ -4434,7 +4434,7 @@
                 </a:solidFill>
                 <a:latin typeface="Calibri"/>
               </a:rPr>
-              <a:t>Sistemul este rapid, scalabil și respectă în totalitate viața privată a utilizatorilor, datele stocându-se exclusiv local.</a:t>
+              <a:t>Divergența matematică dintre canale (ex: mimică senină vs. semantică critică) identifică automat măsura de disociere sau disimulare a pacientului.</a:t>
             </a:r>
           </a:p>
           <a:p>
@@ -4450,7 +4450,7 @@
                 </a:solidFill>
                 <a:latin typeface="Calibri"/>
               </a:rPr>
-              <a:t>Reziliență: </a:t>
+              <a:t>Fuziunea la nivel de decizie (Late Fusion): </a:t>
             </a:r>
             <a:r>
               <a:rPr sz="1300">
@@ -4459,7 +4459,7 @@
                 </a:solidFill>
                 <a:latin typeface="Calibri"/>
               </a:rPr>
-              <a:t>Algoritmii DSP de fallback și interfețele hibride groq-vision garantează funcționarea în parametri optimi chiar și la conexiuni defectuoase.</a:t>
+              <a:t>Agregarea asimetrică a scorurilor permite îmbinarea modelelor rulare local (Edge CNN) cu cele cloud (LLM), optimizând consumul de resurse.</a:t>
             </a:r>
           </a:p>
           <a:p>
@@ -4475,7 +4475,7 @@
                 </a:solidFill>
                 <a:latin typeface="Calibri"/>
               </a:rPr>
-              <a:t>Securitate clinică: </a:t>
+              <a:t>Override semantic de siguranță: </a:t>
             </a:r>
             <a:r>
               <a:rPr sz="1300">
@@ -4484,7 +4484,7 @@
                 </a:solidFill>
                 <a:latin typeface="Calibri"/>
               </a:rPr>
-              <a:t>Algoritmul de carantină împiedică disimularea bruscă a stărilor de risc, forțând menținerea vigilenței clinice.</a:t>
+              <a:t>Prioritizarea sensului clinic al cuvintelor în stări critice (risc &gt;= 80%) elimină riscul de fals-negative cauzate de o intonație vocală calmă sau simulată.</a:t>
             </a:r>
           </a:p>
           <a:p>
@@ -4500,7 +4500,7 @@
                 </a:solidFill>
                 <a:latin typeface="Calibri"/>
               </a:rPr>
-              <a:t>Optimizare resurse: </a:t>
+              <a:t>Conservarea memoriei clinice (Carantina): </a:t>
             </a:r>
             <a:r>
               <a:rPr sz="1300">
@@ -4509,7 +4509,32 @@
                 </a:solidFill>
                 <a:latin typeface="Calibri"/>
               </a:rPr>
-              <a:t>Procesarea locală a imaginilor prin Face-API.js reduce încărcarea serverului și minimizează lățimea de bandă consumată.</a:t>
+              <a:t>Algoritmul de carantină matematică limitează scăderile abrupte de scor (max 15% pe mesaj) prevenind disimularea bruscă a crizelor de către pacienți.</a:t>
+            </a:r>
+          </a:p>
+          <a:p>
+            <a:pPr lvl="1">
+              <a:spcAft>
+                <a:spcPts val="400"/>
+              </a:spcAft>
+            </a:pPr>
+            <a:r>
+              <a:rPr b="1" sz="1300">
+                <a:solidFill>
+                  <a:srgbClr val="334155"/>
+                </a:solidFill>
+                <a:latin typeface="Calibri"/>
+              </a:rPr>
+              <a:t>Reziliență prin arhitectură hibridă: </a:t>
+            </a:r>
+            <a:r>
+              <a:rPr sz="1300">
+                <a:solidFill>
+                  <a:srgbClr val="334155"/>
+                </a:solidFill>
+                <a:latin typeface="Calibri"/>
+              </a:rPr>
+              <a:t>Sistemele offline de tip NumPy/Wave fallback și corecția asincronă Groq Vision asigură un diagnostic stabil chiar și în medii hardware sau de conexiune limitate.</a:t>
             </a:r>
           </a:p>
           <a:p>

</xml_diff>

<commit_message>
docs: enrich Slide 14 future directions with clinical-technical targets
</commit_message>
<xml_diff>
--- a/Prezentare_Licenta_Podean_Beniamin.pptx
+++ b/Prezentare_Licenta_Podean_Beniamin.pptx
@@ -4575,7 +4575,7 @@
                 </a:solidFill>
                 <a:latin typeface="Calibri"/>
               </a:rPr>
-              <a:t>Modelare NLP locală: </a:t>
+              <a:t>Tranziția către Edge LLM (Confidențialitate Zero-Cloud): </a:t>
             </a:r>
             <a:r>
               <a:rPr sz="1300">
@@ -4584,7 +4584,7 @@
                 </a:solidFill>
                 <a:latin typeface="Calibri"/>
               </a:rPr>
-              <a:t>Antrenarea și implementarea de modele lingvistice (Transformer, e.g. BERT românesc) care să ruleze local, fără a depinde de API-uri externe.</a:t>
+              <a:t>Implementarea de modele de limbaj cuantizate local (ex: Llama-3-8B-GGUF via llama.cpp) pentru a elimina complet dependența de API-uri terțe și rețea.</a:t>
             </a:r>
           </a:p>
           <a:p>
@@ -4600,7 +4600,7 @@
                 </a:solidFill>
                 <a:latin typeface="Calibri"/>
               </a:rPr>
-              <a:t>Senzori hardware (IoT): </a:t>
+              <a:t>Integrarea Fiziologică în Sisteme Cyber-Physical (IoT): </a:t>
             </a:r>
             <a:r>
               <a:rPr sz="1300">
@@ -4609,7 +4609,7 @@
                 </a:solidFill>
                 <a:latin typeface="Calibri"/>
               </a:rPr>
-              <a:t>Integrarea cu brățări inteligente sau senzori ECG/pulsoximetru pentru a adăuga parametri fiziologici (variabilitatea ritmului cardiac, conductanța pielii).</a:t>
+              <a:t>Corelarea indicilor multimedia cu biosemnale (Variabilitatea Ritmului Cardiac - HRV, Conductanța Electrodermică - EDA) preluate de senzori purtabili.</a:t>
             </a:r>
           </a:p>
           <a:p>
@@ -4625,7 +4625,7 @@
                 </a:solidFill>
                 <a:latin typeface="Calibri"/>
               </a:rPr>
-              <a:t>Validare clinică controlată: </a:t>
+              <a:t>Aliniere la Standarde Clinice (Interoperabilitate DSS): </a:t>
             </a:r>
             <a:r>
               <a:rPr sz="1300">
@@ -4634,7 +4634,7 @@
                 </a:solidFill>
                 <a:latin typeface="Calibri"/>
               </a:rPr>
-              <a:t>Colaborarea cu medici specialiști pentru testarea pe loturi largi de pacienți diagnosticați pentru validarea coeficienților formulelor de calibrare.</a:t>
+              <a:t>Integrarea cu sisteme de Dosar Electronic de Sănătate (EHR) utilizând protocolul internațional HL7 FHIR pentru a servi ca sistem de suport decizional în clinici.</a:t>
             </a:r>
           </a:p>
         </p:txBody>

</xml_diff>